<commit_message>
docs: fill robot team presentation slide
</commit_message>
<xml_diff>
--- a/docs/report/pres.pptx
+++ b/docs/report/pres.pptx
@@ -12207,8 +12207,8 @@
         </p:nvSpPr>
         <p:spPr>
           <a:xfrm>
-            <a:off x="1005840" y="1737360"/>
-            <a:ext cx="4571640" cy="1830600"/>
+            <a:off x="1005840" y="1690000"/>
+            <a:ext cx="4440000" cy="3320000"/>
           </a:xfrm>
           <a:prstGeom prst="rect">
             <a:avLst/>
@@ -12225,7 +12225,7 @@
           <a:fontRef idx="minor"/>
         </p:style>
         <p:txBody>
-          <a:bodyPr lIns="0" tIns="0" rIns="0" bIns="0" anchor="t">
+          <a:bodyPr lIns="0" tIns="0" rIns="0" bIns="0" anchor="t" wrap="square">
             <a:spAutoFit/>
           </a:bodyPr>
           <a:p>
@@ -12234,9 +12234,18 @@
                 <a:spcPct val="100000"/>
               </a:lnSpc>
               <a:spcAft>
-                <a:spcPts val="2001"/>
+                <a:spcPts val="1000"/>
               </a:spcAft>
-            </a:pPr>
+              <a:defRPr sz="1500" b="1">
+                <a:solidFill>
+                  <a:srgbClr val="2A9FFF"/>
+                </a:solidFill>
+                <a:latin typeface="IBM Plex Sans"/>
+              </a:defRPr>
+            </a:pPr>
+            <a:r>
+              <a:t>ROBOT-SIDE ROS2 PIPELINE</a:t>
+            </a:r>
             <a:endParaRPr lang="en-US" sz="1800" b="0" u="none" strike="noStrike">
               <a:solidFill>
                 <a:srgbClr val="000000"/>
@@ -12245,6 +12254,101 @@
               <a:uFillTx/>
               <a:latin typeface="Arial"/>
             </a:endParaRPr>
+          </a:p>
+          <a:p>
+            <a:pPr>
+              <a:lnSpc>
+                <a:spcPct val="108000"/>
+              </a:lnSpc>
+              <a:spcAft>
+                <a:spcPts val="700"/>
+              </a:spcAft>
+              <a:defRPr sz="1600">
+                <a:solidFill>
+                  <a:srgbClr val="EBEBEB"/>
+                </a:solidFill>
+                <a:latin typeface="IBM Plex Sans"/>
+              </a:defRPr>
+            </a:pPr>
+            <a:r>
+              <a:t>TurtleBot3 Burger + LDS-01 + C920/C270 센서 구성</a:t>
+            </a:r>
+          </a:p>
+          <a:p>
+            <a:pPr>
+              <a:lnSpc>
+                <a:spcPct val="108000"/>
+              </a:lnSpc>
+              <a:spcAft>
+                <a:spcPts val="700"/>
+              </a:spcAft>
+              <a:defRPr sz="1600">
+                <a:solidFill>
+                  <a:srgbClr val="EBEBEB"/>
+                </a:solidFill>
+                <a:latin typeface="IBM Plex Sans"/>
+              </a:defRPr>
+            </a:pPr>
+            <a:r>
+              <a:t>turtlebot3_node, usb_cam, TF/camera frame 연결</a:t>
+            </a:r>
+          </a:p>
+          <a:p>
+            <a:pPr>
+              <a:lnSpc>
+                <a:spcPct val="108000"/>
+              </a:lnSpc>
+              <a:spcAft>
+                <a:spcPts val="700"/>
+              </a:spcAft>
+              <a:defRPr sz="1600">
+                <a:solidFill>
+                  <a:srgbClr val="EBEBEB"/>
+                </a:solidFill>
+                <a:latin typeface="IBM Plex Sans"/>
+              </a:defRPr>
+            </a:pPr>
+            <a:r>
+              <a:t>Xbox 조이스틱 입력 -&gt; UDP bridge -&gt; TwistStamped /cmd_vel</a:t>
+            </a:r>
+          </a:p>
+          <a:p>
+            <a:pPr>
+              <a:lnSpc>
+                <a:spcPct val="108000"/>
+              </a:lnSpc>
+              <a:spcAft>
+                <a:spcPts val="700"/>
+              </a:spcAft>
+              <a:defRPr sz="1600">
+                <a:solidFill>
+                  <a:srgbClr val="EBEBEB"/>
+                </a:solidFill>
+                <a:latin typeface="IBM Plex Sans"/>
+              </a:defRPr>
+            </a:pPr>
+            <a:r>
+              <a:t>SSH deploy / bringup / record / fetch 스크립트로 반복 실험 자동화</a:t>
+            </a:r>
+          </a:p>
+          <a:p>
+            <a:pPr>
+              <a:lnSpc>
+                <a:spcPct val="108000"/>
+              </a:lnSpc>
+              <a:spcAft>
+                <a:spcPts val="700"/>
+              </a:spcAft>
+              <a:defRPr sz="1600">
+                <a:solidFill>
+                  <a:srgbClr val="EBEBEB"/>
+                </a:solidFill>
+                <a:latin typeface="IBM Plex Sans"/>
+              </a:defRPr>
+            </a:pPr>
+            <a:r>
+              <a:t>rosbag2에 /scan, /odom, /tf, dual-camera image/camera_info 기록</a:t>
+            </a:r>
           </a:p>
         </p:txBody>
       </p:sp>
@@ -12360,6 +12464,225 @@
               <a:uFillTx/>
               <a:latin typeface="Calibri"/>
             </a:endParaRPr>
+          </a:p>
+        </p:txBody>
+      </p:sp>
+      <p:sp>
+        <p:nvSpPr>
+          <p:cNvPr id="94" name="Rounded Rectangle 93"/>
+          <p:cNvSpPr/>
+          <p:nvPr/>
+        </p:nvSpPr>
+        <p:spPr>
+          <a:xfrm>
+            <a:off x="1005840" y="5300000"/>
+            <a:ext cx="4240000" cy="620000"/>
+          </a:xfrm>
+          <a:prstGeom prst="roundRect">
+            <a:avLst/>
+          </a:prstGeom>
+          <a:solidFill>
+            <a:srgbClr val="222222"/>
+          </a:solidFill>
+          <a:ln w="15240">
+            <a:solidFill>
+              <a:srgbClr val="2A9FFF"/>
+            </a:solidFill>
+          </a:ln>
+        </p:spPr>
+        <p:style>
+          <a:lnRef idx="1">
+            <a:schemeClr val="accent1"/>
+          </a:lnRef>
+          <a:fillRef idx="3">
+            <a:schemeClr val="accent1"/>
+          </a:fillRef>
+          <a:effectRef idx="2">
+            <a:schemeClr val="accent1"/>
+          </a:effectRef>
+          <a:fontRef idx="minor">
+            <a:schemeClr val="lt1"/>
+          </a:fontRef>
+        </p:style>
+        <p:txBody>
+          <a:bodyPr rtlCol="0" anchor="ctr" lIns="150000" rIns="150000" tIns="55000"/>
+          <a:lstStyle/>
+          <a:p>
+            <a:pPr algn="ctr">
+              <a:defRPr sz="1200" b="1">
+                <a:solidFill>
+                  <a:srgbClr val="DCDCDC"/>
+                </a:solidFill>
+                <a:latin typeface="IBM Plex Sans"/>
+              </a:defRPr>
+            </a:pPr>
+            <a:r>
+              <a:t>HANDOFF  |  LiDAR / odom / camera bag -&gt; visual reconstruction support</a:t>
+            </a:r>
+          </a:p>
+        </p:txBody>
+      </p:sp>
+      <p:pic>
+        <p:nvPicPr>
+          <p:cNvPr id="95" name="Picture 94" descr="robot_front_wide.jpg"/>
+          <p:cNvPicPr>
+            <a:picLocks noChangeAspect="1"/>
+          </p:cNvPicPr>
+          <p:nvPr/>
+        </p:nvPicPr>
+        <p:blipFill>
+          <a:blip r:embed="rId4"/>
+          <a:stretch>
+            <a:fillRect/>
+          </a:stretch>
+        </p:blipFill>
+        <p:spPr>
+          <a:xfrm>
+            <a:off x="6539360" y="1854480"/>
+            <a:ext cx="4660280" cy="1850000"/>
+          </a:xfrm>
+          <a:prstGeom prst="rect">
+            <a:avLst/>
+          </a:prstGeom>
+          <a:ln w="12700">
+            <a:solidFill>
+              <a:srgbClr val="414141"/>
+            </a:solidFill>
+          </a:ln>
+        </p:spPr>
+      </p:pic>
+      <p:pic>
+        <p:nvPicPr>
+          <p:cNvPr id="96" name="Picture 95" descr="robot_mount_wide.jpg"/>
+          <p:cNvPicPr>
+            <a:picLocks noChangeAspect="1"/>
+          </p:cNvPicPr>
+          <p:nvPr/>
+        </p:nvPicPr>
+        <p:blipFill>
+          <a:blip r:embed="rId5"/>
+          <a:stretch>
+            <a:fillRect/>
+          </a:stretch>
+        </p:blipFill>
+        <p:spPr>
+          <a:xfrm>
+            <a:off x="6539360" y="4114480"/>
+            <a:ext cx="4660280" cy="1850000"/>
+          </a:xfrm>
+          <a:prstGeom prst="rect">
+            <a:avLst/>
+          </a:prstGeom>
+          <a:ln w="12700">
+            <a:solidFill>
+              <a:srgbClr val="414141"/>
+            </a:solidFill>
+          </a:ln>
+        </p:spPr>
+      </p:pic>
+      <p:sp>
+        <p:nvSpPr>
+          <p:cNvPr id="97" name="Rectangle 96"/>
+          <p:cNvSpPr/>
+          <p:nvPr/>
+        </p:nvSpPr>
+        <p:spPr>
+          <a:xfrm>
+            <a:off x="6539360" y="3464480"/>
+            <a:ext cx="4660280" cy="240000"/>
+          </a:xfrm>
+          <a:prstGeom prst="rect">
+            <a:avLst/>
+          </a:prstGeom>
+          <a:solidFill>
+            <a:srgbClr val="161616"/>
+          </a:solidFill>
+          <a:ln>
+            <a:noFill/>
+          </a:ln>
+        </p:spPr>
+        <p:style>
+          <a:lnRef idx="1">
+            <a:schemeClr val="accent1"/>
+          </a:lnRef>
+          <a:fillRef idx="3">
+            <a:schemeClr val="accent1"/>
+          </a:fillRef>
+          <a:effectRef idx="2">
+            <a:schemeClr val="accent1"/>
+          </a:effectRef>
+          <a:fontRef idx="minor">
+            <a:schemeClr val="lt1"/>
+          </a:fontRef>
+        </p:style>
+        <p:txBody>
+          <a:bodyPr rtlCol="0" anchor="ctr" wrap="square" lIns="70000" rIns="70000" tIns="15000"/>
+          <a:lstStyle/>
+          <a:p>
+            <a:pPr algn="ctr">
+              <a:defRPr sz="900" b="1">
+                <a:solidFill>
+                  <a:srgbClr val="DADADA"/>
+                </a:solidFill>
+                <a:latin typeface="IBM Plex Sans"/>
+              </a:defRPr>
+            </a:pPr>
+            <a:r>
+              <a:t>REAL ROBOT  |  TurtleBot3 Burger + dual USB webcams + LDS-01</a:t>
+            </a:r>
+          </a:p>
+        </p:txBody>
+      </p:sp>
+      <p:sp>
+        <p:nvSpPr>
+          <p:cNvPr id="98" name="Rectangle 97"/>
+          <p:cNvSpPr/>
+          <p:nvPr/>
+        </p:nvSpPr>
+        <p:spPr>
+          <a:xfrm>
+            <a:off x="6539360" y="5724480"/>
+            <a:ext cx="4660280" cy="240000"/>
+          </a:xfrm>
+          <a:prstGeom prst="rect">
+            <a:avLst/>
+          </a:prstGeom>
+          <a:solidFill>
+            <a:srgbClr val="161616"/>
+          </a:solidFill>
+          <a:ln>
+            <a:noFill/>
+          </a:ln>
+        </p:spPr>
+        <p:style>
+          <a:lnRef idx="1">
+            <a:schemeClr val="accent1"/>
+          </a:lnRef>
+          <a:fillRef idx="3">
+            <a:schemeClr val="accent1"/>
+          </a:fillRef>
+          <a:effectRef idx="2">
+            <a:schemeClr val="accent1"/>
+          </a:effectRef>
+          <a:fontRef idx="minor">
+            <a:schemeClr val="lt1"/>
+          </a:fontRef>
+        </p:style>
+        <p:txBody>
+          <a:bodyPr rtlCol="0" anchor="ctr" wrap="square" lIns="70000" rIns="70000" tIns="15000"/>
+          <a:lstStyle/>
+          <a:p>
+            <a:pPr algn="ctr">
+              <a:defRPr sz="850" b="1">
+                <a:solidFill>
+                  <a:srgbClr val="DADADA"/>
+                </a:solidFill>
+                <a:latin typeface="IBM Plex Sans"/>
+              </a:defRPr>
+            </a:pPr>
+            <a:r>
+              <a:t>HARDWARE MOUNT  |  C920 / C270 camera integration for scan recording</a:t>
+            </a:r>
           </a:p>
         </p:txBody>
       </p:sp>

</xml_diff>

<commit_message>
docs: add simulation presentation slide
</commit_message>
<xml_diff>
--- a/docs/report/pres.pptx
+++ b/docs/report/pres.pptx
@@ -9,6 +9,7 @@
     <p:sldId id="257" r:id="rId4"/>
     <p:sldId id="258" r:id="rId5"/>
     <p:sldId id="259" r:id="rId6"/>
+    <p:sldId id="267" r:id="rId15"/>
     <p:sldId id="260" r:id="rId7"/>
     <p:sldId id="261" r:id="rId8"/>
     <p:sldId id="262" r:id="rId9"/>
@@ -7757,6 +7758,1255 @@
       </p:grpSpPr>
       <p:sp>
         <p:nvSpPr>
+          <p:cNvPr id="136" name="Rectangle 1"/>
+          <p:cNvSpPr/>
+          <p:nvPr/>
+        </p:nvSpPr>
+        <p:spPr>
+          <a:xfrm>
+            <a:off x="0" y="0"/>
+            <a:ext cx="12191400" cy="6857640"/>
+          </a:xfrm>
+          <a:prstGeom prst="rect">
+            <a:avLst/>
+          </a:prstGeom>
+          <a:solidFill>
+            <a:srgbClr val="161616"/>
+          </a:solidFill>
+          <a:ln>
+            <a:noFill/>
+          </a:ln>
+          <a:effectLst>
+            <a:outerShdw blurRad="39960" dir="5400000" dist="23040" rotWithShape="0">
+              <a:srgbClr val="000000">
+                <a:alpha val="35000"/>
+              </a:srgbClr>
+            </a:outerShdw>
+          </a:effectLst>
+        </p:spPr>
+        <p:style>
+          <a:lnRef idx="1">
+            <a:schemeClr val="accent1"/>
+          </a:lnRef>
+          <a:fillRef idx="3">
+            <a:schemeClr val="accent1"/>
+          </a:fillRef>
+          <a:effectRef idx="2">
+            <a:schemeClr val="accent1"/>
+          </a:effectRef>
+          <a:fontRef idx="minor"/>
+        </p:style>
+        <p:txBody>
+          <a:bodyPr lIns="90000" tIns="45000" rIns="90000" bIns="45000" anchor="ctr">
+            <a:noAutofit/>
+          </a:bodyPr>
+          <a:p>
+            <a:endParaRPr lang="en-US" sz="1800" b="0" u="none" strike="noStrike">
+              <a:solidFill>
+                <a:schemeClr val="lt1"/>
+              </a:solidFill>
+              <a:effectLst/>
+              <a:uFillTx/>
+              <a:latin typeface="Calibri"/>
+            </a:endParaRPr>
+          </a:p>
+        </p:txBody>
+      </p:sp>
+      <p:sp>
+        <p:nvSpPr>
+          <p:cNvPr id="137" name="TextBox 2"/>
+          <p:cNvSpPr/>
+          <p:nvPr/>
+        </p:nvSpPr>
+        <p:spPr>
+          <a:xfrm>
+            <a:off x="731520" y="365760"/>
+            <a:ext cx="10728360" cy="273960"/>
+          </a:xfrm>
+          <a:prstGeom prst="rect">
+            <a:avLst/>
+          </a:prstGeom>
+          <a:noFill/>
+          <a:ln w="0">
+            <a:noFill/>
+          </a:ln>
+        </p:spPr>
+        <p:style>
+          <a:lnRef idx="0"/>
+          <a:fillRef idx="0"/>
+          <a:effectRef idx="0"/>
+          <a:fontRef idx="minor"/>
+        </p:style>
+        <p:txBody>
+          <a:bodyPr lIns="0" tIns="0" rIns="0" bIns="0" anchor="t">
+            <a:spAutoFit/>
+          </a:bodyPr>
+          <a:p>
+            <a:pPr defTabSz="457200">
+              <a:lnSpc>
+                <a:spcPct val="100000"/>
+              </a:lnSpc>
+            </a:pPr>
+            <a:r>
+              <a:rPr lang="en-US" sz="1000" b="1" u="none" strike="noStrike">
+                <a:solidFill>
+                  <a:srgbClr val="8D8D8D"/>
+                </a:solidFill>
+                <a:effectLst/>
+                <a:uFillTx/>
+                <a:latin typeface="IBM Plex Sans"/>
+              </a:rPr>
+              <a:t>07 // FINAL OUTCOME</a:t>
+            </a:r>
+            <a:endParaRPr lang="en-US" sz="1000" b="0" u="none" strike="noStrike">
+              <a:solidFill>
+                <a:srgbClr val="000000"/>
+              </a:solidFill>
+              <a:effectLst/>
+              <a:uFillTx/>
+              <a:latin typeface="Arial"/>
+            </a:endParaRPr>
+          </a:p>
+        </p:txBody>
+      </p:sp>
+      <p:sp>
+        <p:nvSpPr>
+          <p:cNvPr id="138" name="TextBox 3"/>
+          <p:cNvSpPr/>
+          <p:nvPr/>
+        </p:nvSpPr>
+        <p:spPr>
+          <a:xfrm>
+            <a:off x="731520" y="594360"/>
+            <a:ext cx="10728360" cy="366120"/>
+          </a:xfrm>
+          <a:prstGeom prst="rect">
+            <a:avLst/>
+          </a:prstGeom>
+          <a:noFill/>
+          <a:ln w="0">
+            <a:noFill/>
+          </a:ln>
+        </p:spPr>
+        <p:style>
+          <a:lnRef idx="0"/>
+          <a:fillRef idx="0"/>
+          <a:effectRef idx="0"/>
+          <a:fontRef idx="minor"/>
+        </p:style>
+        <p:txBody>
+          <a:bodyPr lIns="0" tIns="0" rIns="0" bIns="0" anchor="t">
+            <a:spAutoFit/>
+          </a:bodyPr>
+          <a:p>
+            <a:pPr defTabSz="457200">
+              <a:lnSpc>
+                <a:spcPct val="100000"/>
+              </a:lnSpc>
+            </a:pPr>
+            <a:r>
+              <a:rPr lang="en-US" sz="2400" b="1" u="none" strike="noStrike">
+                <a:solidFill>
+                  <a:srgbClr val="FFFFFF"/>
+                </a:solidFill>
+                <a:effectLst/>
+                <a:uFillTx/>
+                <a:latin typeface="IBM Plex Sans"/>
+              </a:rPr>
+              <a:t>Edge-Textured True 3D Map</a:t>
+            </a:r>
+            <a:endParaRPr lang="en-US" sz="2400" b="0" u="none" strike="noStrike">
+              <a:solidFill>
+                <a:srgbClr val="000000"/>
+              </a:solidFill>
+              <a:effectLst/>
+              <a:uFillTx/>
+              <a:latin typeface="Arial"/>
+            </a:endParaRPr>
+          </a:p>
+        </p:txBody>
+      </p:sp>
+      <p:sp>
+        <p:nvSpPr>
+          <p:cNvPr id="139" name="Rectangle 4"/>
+          <p:cNvSpPr/>
+          <p:nvPr/>
+        </p:nvSpPr>
+        <p:spPr>
+          <a:xfrm>
+            <a:off x="731520" y="1188720"/>
+            <a:ext cx="10728360" cy="18000"/>
+          </a:xfrm>
+          <a:prstGeom prst="rect">
+            <a:avLst/>
+          </a:prstGeom>
+          <a:solidFill>
+            <a:srgbClr val="393939"/>
+          </a:solidFill>
+          <a:ln>
+            <a:noFill/>
+          </a:ln>
+          <a:effectLst>
+            <a:outerShdw blurRad="39960" dir="5400000" dist="23040" rotWithShape="0">
+              <a:srgbClr val="000000">
+                <a:alpha val="35000"/>
+              </a:srgbClr>
+            </a:outerShdw>
+          </a:effectLst>
+        </p:spPr>
+        <p:style>
+          <a:lnRef idx="1">
+            <a:schemeClr val="accent1"/>
+          </a:lnRef>
+          <a:fillRef idx="3">
+            <a:schemeClr val="accent1"/>
+          </a:fillRef>
+          <a:effectRef idx="2">
+            <a:schemeClr val="accent1"/>
+          </a:effectRef>
+          <a:fontRef idx="minor"/>
+        </p:style>
+        <p:txBody>
+          <a:bodyPr lIns="90000" tIns="-26640" rIns="90000" bIns="-26640" anchor="ctr">
+            <a:noAutofit/>
+          </a:bodyPr>
+          <a:p>
+            <a:endParaRPr lang="en-US" sz="1800" b="0" u="none" strike="noStrike">
+              <a:solidFill>
+                <a:schemeClr val="lt1"/>
+              </a:solidFill>
+              <a:effectLst/>
+              <a:uFillTx/>
+              <a:latin typeface="Calibri"/>
+            </a:endParaRPr>
+          </a:p>
+        </p:txBody>
+      </p:sp>
+      <p:sp>
+        <p:nvSpPr>
+          <p:cNvPr id="140" name="Rectangle 5"/>
+          <p:cNvSpPr/>
+          <p:nvPr/>
+        </p:nvSpPr>
+        <p:spPr>
+          <a:xfrm>
+            <a:off x="731520" y="1554480"/>
+            <a:ext cx="5120280" cy="4571640"/>
+          </a:xfrm>
+          <a:prstGeom prst="rect">
+            <a:avLst/>
+          </a:prstGeom>
+          <a:solidFill>
+            <a:srgbClr val="262626"/>
+          </a:solidFill>
+          <a:ln w="12700">
+            <a:solidFill>
+              <a:srgbClr val="393939"/>
+            </a:solidFill>
+            <a:round/>
+          </a:ln>
+          <a:effectLst>
+            <a:outerShdw blurRad="39960" dir="5400000" dist="23040" rotWithShape="0">
+              <a:srgbClr val="000000">
+                <a:alpha val="35000"/>
+              </a:srgbClr>
+            </a:outerShdw>
+          </a:effectLst>
+        </p:spPr>
+        <p:style>
+          <a:lnRef idx="1">
+            <a:schemeClr val="accent1"/>
+          </a:lnRef>
+          <a:fillRef idx="3">
+            <a:schemeClr val="accent1"/>
+          </a:fillRef>
+          <a:effectRef idx="2">
+            <a:schemeClr val="accent1"/>
+          </a:effectRef>
+          <a:fontRef idx="minor"/>
+        </p:style>
+        <p:txBody>
+          <a:bodyPr lIns="90000" tIns="45000" rIns="90000" bIns="45000" anchor="ctr">
+            <a:noAutofit/>
+          </a:bodyPr>
+          <a:p>
+            <a:endParaRPr lang="en-US" sz="1800" b="0" u="none" strike="noStrike">
+              <a:solidFill>
+                <a:schemeClr val="lt1"/>
+              </a:solidFill>
+              <a:effectLst/>
+              <a:uFillTx/>
+              <a:latin typeface="Calibri"/>
+            </a:endParaRPr>
+          </a:p>
+        </p:txBody>
+      </p:sp>
+      <p:sp>
+        <p:nvSpPr>
+          <p:cNvPr id="141" name="Rectangle 6"/>
+          <p:cNvSpPr/>
+          <p:nvPr/>
+        </p:nvSpPr>
+        <p:spPr>
+          <a:xfrm>
+            <a:off x="731520" y="1554480"/>
+            <a:ext cx="72720" cy="4571640"/>
+          </a:xfrm>
+          <a:prstGeom prst="rect">
+            <a:avLst/>
+          </a:prstGeom>
+          <a:solidFill>
+            <a:srgbClr val="24A148"/>
+          </a:solidFill>
+          <a:ln>
+            <a:noFill/>
+          </a:ln>
+          <a:effectLst>
+            <a:outerShdw blurRad="39960" dir="5400000" dist="23040" rotWithShape="0">
+              <a:srgbClr val="000000">
+                <a:alpha val="35000"/>
+              </a:srgbClr>
+            </a:outerShdw>
+          </a:effectLst>
+        </p:spPr>
+        <p:style>
+          <a:lnRef idx="1">
+            <a:schemeClr val="accent1"/>
+          </a:lnRef>
+          <a:fillRef idx="3">
+            <a:schemeClr val="accent1"/>
+          </a:fillRef>
+          <a:effectRef idx="2">
+            <a:schemeClr val="accent1"/>
+          </a:effectRef>
+          <a:fontRef idx="minor"/>
+        </p:style>
+        <p:txBody>
+          <a:bodyPr lIns="90000" tIns="45000" rIns="90000" bIns="45000" anchor="ctr">
+            <a:noAutofit/>
+          </a:bodyPr>
+          <a:p>
+            <a:endParaRPr lang="en-US" sz="1800" b="0" u="none" strike="noStrike">
+              <a:solidFill>
+                <a:schemeClr val="lt1"/>
+              </a:solidFill>
+              <a:effectLst/>
+              <a:uFillTx/>
+              <a:latin typeface="Calibri"/>
+            </a:endParaRPr>
+          </a:p>
+        </p:txBody>
+      </p:sp>
+      <p:sp>
+        <p:nvSpPr>
+          <p:cNvPr id="142" name="TextBox 7"/>
+          <p:cNvSpPr/>
+          <p:nvPr/>
+        </p:nvSpPr>
+        <p:spPr>
+          <a:xfrm>
+            <a:off x="1005840" y="1737360"/>
+            <a:ext cx="4571640" cy="2725560"/>
+          </a:xfrm>
+          <a:prstGeom prst="rect">
+            <a:avLst/>
+          </a:prstGeom>
+          <a:noFill/>
+          <a:ln w="0">
+            <a:noFill/>
+          </a:ln>
+        </p:spPr>
+        <p:style>
+          <a:lnRef idx="0"/>
+          <a:fillRef idx="0"/>
+          <a:effectRef idx="0"/>
+          <a:fontRef idx="minor"/>
+        </p:style>
+        <p:txBody>
+          <a:bodyPr lIns="0" tIns="0" rIns="0" bIns="0" anchor="t">
+            <a:spAutoFit/>
+          </a:bodyPr>
+          <a:p>
+            <a:pPr defTabSz="457200">
+              <a:lnSpc>
+                <a:spcPct val="100000"/>
+              </a:lnSpc>
+              <a:spcAft>
+                <a:spcPts val="2001"/>
+              </a:spcAft>
+            </a:pPr>
+            <a:r>
+              <a:rPr lang="en-US" sz="1200" b="1" u="none" strike="noStrike">
+                <a:solidFill>
+                  <a:srgbClr val="24A148"/>
+                </a:solidFill>
+                <a:effectLst/>
+                <a:uFillTx/>
+                <a:latin typeface="Calibri"/>
+              </a:rPr>
+              <a:t>EDGE-TEXTURED TRUE 3D MAP</a:t>
+            </a:r>
+            <a:endParaRPr lang="en-US" sz="1200" b="0" u="none" strike="noStrike">
+              <a:solidFill>
+                <a:srgbClr val="000000"/>
+              </a:solidFill>
+              <a:effectLst/>
+              <a:uFillTx/>
+              <a:latin typeface="Arial"/>
+            </a:endParaRPr>
+          </a:p>
+          <a:p>
+            <a:pPr defTabSz="457200">
+              <a:lnSpc>
+                <a:spcPct val="100000"/>
+              </a:lnSpc>
+              <a:spcAft>
+                <a:spcPts val="799"/>
+              </a:spcAft>
+            </a:pPr>
+            <a:r>
+              <a:rPr lang="en-US" sz="1300" b="1" u="none" strike="noStrike">
+                <a:solidFill>
+                  <a:srgbClr val="FFFFFF"/>
+                </a:solidFill>
+                <a:effectLst/>
+                <a:uFillTx/>
+                <a:latin typeface="IBM Plex Sans"/>
+              </a:rPr>
+              <a:t>• 최종 통합 매핑 솔루션</a:t>
+            </a:r>
+            <a:r>
+              <a:rPr lang="en-US" sz="1300" b="1" u="none" strike="noStrike">
+                <a:solidFill>
+                  <a:srgbClr val="FFFFFF"/>
+                </a:solidFill>
+                <a:effectLst/>
+                <a:uFillTx/>
+                <a:latin typeface="IBM Plex Sans"/>
+              </a:rPr>
+              <a:t>: </a:t>
+            </a:r>
+            <a:r>
+              <a:rPr lang="zh-CN" sz="1300" b="0" u="none" strike="noStrike">
+                <a:solidFill>
+                  <a:srgbClr val="C6C6C6"/>
+                </a:solidFill>
+                <a:effectLst/>
+                <a:uFillTx/>
+                <a:latin typeface="IBM Plex Sans"/>
+              </a:rPr>
+              <a:t>카메라의 에지와 </a:t>
+            </a:r>
+            <a:r>
+              <a:rPr lang="en-US" sz="1300" b="0" u="none" strike="noStrike">
+                <a:solidFill>
+                  <a:srgbClr val="C6C6C6"/>
+                </a:solidFill>
+                <a:effectLst/>
+                <a:uFillTx/>
+                <a:latin typeface="IBM Plex Sans"/>
+              </a:rPr>
+              <a:t>LiDAR </a:t>
+            </a:r>
+            <a:r>
+              <a:rPr lang="zh-CN" sz="1300" b="0" u="none" strike="noStrike">
+                <a:solidFill>
+                  <a:srgbClr val="C6C6C6"/>
+                </a:solidFill>
+                <a:effectLst/>
+                <a:uFillTx/>
+                <a:latin typeface="IBM Plex Sans"/>
+              </a:rPr>
+              <a:t>벽면 그리드를 결합하여 실제 벽면에 이미지를 입히는 최신 기법 적용</a:t>
+            </a:r>
+            <a:r>
+              <a:rPr lang="en-US" sz="1300" b="0" u="none" strike="noStrike">
+                <a:solidFill>
+                  <a:srgbClr val="C6C6C6"/>
+                </a:solidFill>
+                <a:effectLst/>
+                <a:uFillTx/>
+                <a:latin typeface="IBM Plex Sans"/>
+              </a:rPr>
+              <a:t>.</a:t>
+            </a:r>
+            <a:endParaRPr lang="en-US" sz="1300" b="0" u="none" strike="noStrike">
+              <a:solidFill>
+                <a:srgbClr val="000000"/>
+              </a:solidFill>
+              <a:effectLst/>
+              <a:uFillTx/>
+              <a:latin typeface="Arial"/>
+            </a:endParaRPr>
+          </a:p>
+          <a:p>
+            <a:pPr defTabSz="457200">
+              <a:lnSpc>
+                <a:spcPct val="100000"/>
+              </a:lnSpc>
+              <a:spcAft>
+                <a:spcPts val="799"/>
+              </a:spcAft>
+            </a:pPr>
+            <a:r>
+              <a:rPr lang="en-US" sz="1300" b="1" u="none" strike="noStrike">
+                <a:solidFill>
+                  <a:srgbClr val="FFFFFF"/>
+                </a:solidFill>
+                <a:effectLst/>
+                <a:uFillTx/>
+                <a:latin typeface="IBM Plex Sans"/>
+              </a:rPr>
+              <a:t>• Raycast </a:t>
+            </a:r>
+            <a:r>
+              <a:rPr lang="zh-CN" sz="1300" b="1" u="none" strike="noStrike">
+                <a:solidFill>
+                  <a:srgbClr val="FFFFFF"/>
+                </a:solidFill>
+                <a:effectLst/>
+                <a:uFillTx/>
+                <a:latin typeface="IBM Plex Sans"/>
+              </a:rPr>
+              <a:t>기반 매칭</a:t>
+            </a:r>
+            <a:r>
+              <a:rPr lang="en-US" sz="1300" b="1" u="none" strike="noStrike">
+                <a:solidFill>
+                  <a:srgbClr val="FFFFFF"/>
+                </a:solidFill>
+                <a:effectLst/>
+                <a:uFillTx/>
+                <a:latin typeface="IBM Plex Sans"/>
+              </a:rPr>
+              <a:t>: </a:t>
+            </a:r>
+            <a:r>
+              <a:rPr lang="zh-CN" sz="1300" b="0" u="none" strike="noStrike">
+                <a:solidFill>
+                  <a:srgbClr val="C6C6C6"/>
+                </a:solidFill>
+                <a:effectLst/>
+                <a:uFillTx/>
+                <a:latin typeface="IBM Plex Sans"/>
+              </a:rPr>
+              <a:t>각 </a:t>
+            </a:r>
+            <a:r>
+              <a:rPr lang="en-US" sz="1300" b="0" u="none" strike="noStrike">
+                <a:solidFill>
+                  <a:srgbClr val="C6C6C6"/>
+                </a:solidFill>
+                <a:effectLst/>
+                <a:uFillTx/>
+                <a:latin typeface="IBM Plex Sans"/>
+              </a:rPr>
+              <a:t>run</a:t>
+            </a:r>
+            <a:r>
+              <a:rPr lang="zh-CN" sz="1300" b="0" u="none" strike="noStrike">
+                <a:solidFill>
+                  <a:srgbClr val="C6C6C6"/>
+                </a:solidFill>
+                <a:effectLst/>
+                <a:uFillTx/>
+                <a:latin typeface="IBM Plex Sans"/>
+              </a:rPr>
+              <a:t>에서 </a:t>
+            </a:r>
+            <a:r>
+              <a:rPr lang="en-US" sz="1300" b="0" u="none" strike="noStrike">
+                <a:solidFill>
+                  <a:srgbClr val="C6C6C6"/>
+                </a:solidFill>
+                <a:effectLst/>
+                <a:uFillTx/>
+                <a:latin typeface="IBM Plex Sans"/>
+              </a:rPr>
+              <a:t>C920 </a:t>
+            </a:r>
+            <a:r>
+              <a:rPr lang="zh-CN" sz="1300" b="0" u="none" strike="noStrike">
+                <a:solidFill>
+                  <a:srgbClr val="C6C6C6"/>
+                </a:solidFill>
+                <a:effectLst/>
+                <a:uFillTx/>
+                <a:latin typeface="IBM Plex Sans"/>
+              </a:rPr>
+              <a:t>프레임 </a:t>
+            </a:r>
+            <a:r>
+              <a:rPr lang="en-US" sz="1300" b="0" u="none" strike="noStrike">
+                <a:solidFill>
+                  <a:srgbClr val="C6C6C6"/>
+                </a:solidFill>
+                <a:effectLst/>
+                <a:uFillTx/>
+                <a:latin typeface="IBM Plex Sans"/>
+              </a:rPr>
+              <a:t>18</a:t>
+            </a:r>
+            <a:r>
+              <a:rPr lang="zh-CN" sz="1300" b="0" u="none" strike="noStrike">
+                <a:solidFill>
+                  <a:srgbClr val="C6C6C6"/>
+                </a:solidFill>
+                <a:effectLst/>
+                <a:uFillTx/>
+                <a:latin typeface="IBM Plex Sans"/>
+              </a:rPr>
+              <a:t>개를 추출하고 </a:t>
+            </a:r>
+            <a:r>
+              <a:rPr lang="en-US" sz="1300" b="0" u="none" strike="noStrike">
+                <a:solidFill>
+                  <a:srgbClr val="C6C6C6"/>
+                </a:solidFill>
+                <a:effectLst/>
+                <a:uFillTx/>
+                <a:latin typeface="IBM Plex Sans"/>
+              </a:rPr>
+              <a:t>3</a:t>
+            </a:r>
+            <a:r>
+              <a:rPr lang="zh-CN" sz="1300" b="0" u="none" strike="noStrike">
+                <a:solidFill>
+                  <a:srgbClr val="C6C6C6"/>
+                </a:solidFill>
+                <a:effectLst/>
+                <a:uFillTx/>
+                <a:latin typeface="IBM Plex Sans"/>
+              </a:rPr>
+              <a:t>개 영역 패치로 분할</a:t>
+            </a:r>
+            <a:r>
+              <a:rPr lang="en-US" sz="1300" b="0" u="none" strike="noStrike">
+                <a:solidFill>
+                  <a:srgbClr val="C6C6C6"/>
+                </a:solidFill>
+                <a:effectLst/>
+                <a:uFillTx/>
+                <a:latin typeface="IBM Plex Sans"/>
+              </a:rPr>
+              <a:t>, Canny edge </a:t>
+            </a:r>
+            <a:r>
+              <a:rPr lang="zh-CN" sz="1300" b="0" u="none" strike="noStrike">
+                <a:solidFill>
+                  <a:srgbClr val="C6C6C6"/>
+                </a:solidFill>
+                <a:effectLst/>
+                <a:uFillTx/>
+                <a:latin typeface="IBM Plex Sans"/>
+              </a:rPr>
+              <a:t>및 </a:t>
+            </a:r>
+            <a:r>
+              <a:rPr lang="en-US" sz="1300" b="0" u="none" strike="noStrike">
+                <a:solidFill>
+                  <a:srgbClr val="C6C6C6"/>
+                </a:solidFill>
+                <a:effectLst/>
+                <a:uFillTx/>
+                <a:latin typeface="IBM Plex Sans"/>
+              </a:rPr>
+              <a:t>contour </a:t>
+            </a:r>
+            <a:r>
+              <a:rPr lang="zh-CN" sz="1300" b="0" u="none" strike="noStrike">
+                <a:solidFill>
+                  <a:srgbClr val="C6C6C6"/>
+                </a:solidFill>
+                <a:effectLst/>
+                <a:uFillTx/>
+                <a:latin typeface="IBM Plex Sans"/>
+              </a:rPr>
+              <a:t>계산 후 </a:t>
+            </a:r>
+            <a:r>
+              <a:rPr lang="en-US" sz="1300" b="0" u="none" strike="noStrike">
+                <a:solidFill>
+                  <a:srgbClr val="C6C6C6"/>
+                </a:solidFill>
+                <a:effectLst/>
+                <a:uFillTx/>
+                <a:latin typeface="IBM Plex Sans"/>
+              </a:rPr>
+              <a:t>LiDAR </a:t>
+            </a:r>
+            <a:r>
+              <a:rPr lang="zh-CN" sz="1300" b="0" u="none" strike="noStrike">
+                <a:solidFill>
+                  <a:srgbClr val="C6C6C6"/>
+                </a:solidFill>
+                <a:effectLst/>
+                <a:uFillTx/>
+                <a:latin typeface="IBM Plex Sans"/>
+              </a:rPr>
+              <a:t>바운더리에 매칭</a:t>
+            </a:r>
+            <a:r>
+              <a:rPr lang="en-US" sz="1300" b="0" u="none" strike="noStrike">
+                <a:solidFill>
+                  <a:srgbClr val="C6C6C6"/>
+                </a:solidFill>
+                <a:effectLst/>
+                <a:uFillTx/>
+                <a:latin typeface="IBM Plex Sans"/>
+              </a:rPr>
+              <a:t>.</a:t>
+            </a:r>
+            <a:endParaRPr lang="en-US" sz="1300" b="0" u="none" strike="noStrike">
+              <a:solidFill>
+                <a:srgbClr val="000000"/>
+              </a:solidFill>
+              <a:effectLst/>
+              <a:uFillTx/>
+              <a:latin typeface="Arial"/>
+            </a:endParaRPr>
+          </a:p>
+          <a:p>
+            <a:pPr defTabSz="457200">
+              <a:lnSpc>
+                <a:spcPct val="100000"/>
+              </a:lnSpc>
+              <a:spcAft>
+                <a:spcPts val="799"/>
+              </a:spcAft>
+            </a:pPr>
+            <a:r>
+              <a:rPr lang="en-US" sz="1300" b="1" u="none" strike="noStrike">
+                <a:solidFill>
+                  <a:srgbClr val="FFFFFF"/>
+                </a:solidFill>
+                <a:effectLst/>
+                <a:uFillTx/>
+                <a:latin typeface="IBM Plex Sans"/>
+              </a:rPr>
+              <a:t>• 수직 텍스처 패널 배치</a:t>
+            </a:r>
+            <a:r>
+              <a:rPr lang="en-US" sz="1300" b="1" u="none" strike="noStrike">
+                <a:solidFill>
+                  <a:srgbClr val="FFFFFF"/>
+                </a:solidFill>
+                <a:effectLst/>
+                <a:uFillTx/>
+                <a:latin typeface="IBM Plex Sans"/>
+              </a:rPr>
+              <a:t>: </a:t>
+            </a:r>
+            <a:r>
+              <a:rPr lang="zh-CN" sz="1300" b="0" u="none" strike="noStrike">
+                <a:solidFill>
+                  <a:srgbClr val="C6C6C6"/>
+                </a:solidFill>
+                <a:effectLst/>
+                <a:uFillTx/>
+                <a:latin typeface="IBM Plex Sans"/>
+              </a:rPr>
+              <a:t>실제 물체가 있는 곳에 </a:t>
+            </a:r>
+            <a:r>
+              <a:rPr lang="en-US" sz="1300" b="0" u="none" strike="noStrike">
+                <a:solidFill>
+                  <a:srgbClr val="C6C6C6"/>
+                </a:solidFill>
+                <a:effectLst/>
+                <a:uFillTx/>
+                <a:latin typeface="IBM Plex Sans"/>
+              </a:rPr>
+              <a:t>90</a:t>
+            </a:r>
+            <a:r>
+              <a:rPr lang="zh-CN" sz="1300" b="0" u="none" strike="noStrike">
+                <a:solidFill>
+                  <a:srgbClr val="C6C6C6"/>
+                </a:solidFill>
+                <a:effectLst/>
+                <a:uFillTx/>
+                <a:latin typeface="IBM Plex Sans"/>
+              </a:rPr>
+              <a:t>개의 </a:t>
+            </a:r>
+            <a:r>
+              <a:rPr lang="en-US" sz="1300" b="0" u="none" strike="noStrike">
+                <a:solidFill>
+                  <a:srgbClr val="C6C6C6"/>
+                </a:solidFill>
+                <a:effectLst/>
+                <a:uFillTx/>
+                <a:latin typeface="IBM Plex Sans"/>
+              </a:rPr>
+              <a:t>Edge-textured vertical panel</a:t>
+            </a:r>
+            <a:r>
+              <a:rPr lang="zh-CN" sz="1300" b="0" u="none" strike="noStrike">
+                <a:solidFill>
+                  <a:srgbClr val="C6C6C6"/>
+                </a:solidFill>
+                <a:effectLst/>
+                <a:uFillTx/>
+                <a:latin typeface="IBM Plex Sans"/>
+              </a:rPr>
+              <a:t>을 적재적소에 빌딩함</a:t>
+            </a:r>
+            <a:r>
+              <a:rPr lang="en-US" sz="1300" b="0" u="none" strike="noStrike">
+                <a:solidFill>
+                  <a:srgbClr val="C6C6C6"/>
+                </a:solidFill>
+                <a:effectLst/>
+                <a:uFillTx/>
+                <a:latin typeface="IBM Plex Sans"/>
+              </a:rPr>
+              <a:t>.</a:t>
+            </a:r>
+            <a:endParaRPr lang="en-US" sz="1300" b="0" u="none" strike="noStrike">
+              <a:solidFill>
+                <a:srgbClr val="000000"/>
+              </a:solidFill>
+              <a:effectLst/>
+              <a:uFillTx/>
+              <a:latin typeface="Arial"/>
+            </a:endParaRPr>
+          </a:p>
+          <a:p>
+            <a:pPr defTabSz="457200">
+              <a:lnSpc>
+                <a:spcPct val="100000"/>
+              </a:lnSpc>
+              <a:spcAft>
+                <a:spcPts val="799"/>
+              </a:spcAft>
+            </a:pPr>
+            <a:r>
+              <a:rPr lang="en-US" sz="1300" b="1" u="none" strike="noStrike">
+                <a:solidFill>
+                  <a:srgbClr val="FFFFFF"/>
+                </a:solidFill>
+                <a:effectLst/>
+                <a:uFillTx/>
+                <a:latin typeface="IBM Plex Sans"/>
+              </a:rPr>
+              <a:t>• 좌표 축 </a:t>
+            </a:r>
+            <a:r>
+              <a:rPr lang="en-US" sz="1300" b="1" u="none" strike="noStrike">
+                <a:solidFill>
+                  <a:srgbClr val="FFFFFF"/>
+                </a:solidFill>
+                <a:effectLst/>
+                <a:uFillTx/>
+                <a:latin typeface="IBM Plex Sans"/>
+              </a:rPr>
+              <a:t>Yaw </a:t>
+            </a:r>
+            <a:r>
+              <a:rPr lang="zh-CN" sz="1300" b="1" u="none" strike="noStrike">
+                <a:solidFill>
+                  <a:srgbClr val="FFFFFF"/>
+                </a:solidFill>
+                <a:effectLst/>
+                <a:uFillTx/>
+                <a:latin typeface="IBM Plex Sans"/>
+              </a:rPr>
+              <a:t>버그 해결</a:t>
+            </a:r>
+            <a:r>
+              <a:rPr lang="en-US" sz="1300" b="1" u="none" strike="noStrike">
+                <a:solidFill>
+                  <a:srgbClr val="FFFFFF"/>
+                </a:solidFill>
+                <a:effectLst/>
+                <a:uFillTx/>
+                <a:latin typeface="IBM Plex Sans"/>
+              </a:rPr>
+              <a:t>: </a:t>
+            </a:r>
+            <a:r>
+              <a:rPr lang="en-US" sz="1300" b="0" u="none" strike="noStrike">
+                <a:solidFill>
+                  <a:srgbClr val="C6C6C6"/>
+                </a:solidFill>
+                <a:effectLst/>
+                <a:uFillTx/>
+                <a:latin typeface="IBM Plex Sans"/>
+              </a:rPr>
+              <a:t>ROS(odom) </a:t>
+            </a:r>
+            <a:r>
+              <a:rPr lang="zh-CN" sz="1300" b="0" u="none" strike="noStrike">
+                <a:solidFill>
+                  <a:srgbClr val="C6C6C6"/>
+                </a:solidFill>
+                <a:effectLst/>
+                <a:uFillTx/>
+                <a:latin typeface="IBM Plex Sans"/>
+              </a:rPr>
+              <a:t>좌표계와 </a:t>
+            </a:r>
+            <a:r>
+              <a:rPr lang="en-US" sz="1300" b="0" u="none" strike="noStrike">
+                <a:solidFill>
+                  <a:srgbClr val="C6C6C6"/>
+                </a:solidFill>
+                <a:effectLst/>
+                <a:uFillTx/>
+                <a:latin typeface="IBM Plex Sans"/>
+              </a:rPr>
+              <a:t>WebGL</a:t>
+            </a:r>
+            <a:r>
+              <a:rPr lang="zh-CN" sz="1300" b="0" u="none" strike="noStrike">
+                <a:solidFill>
+                  <a:srgbClr val="C6C6C6"/>
+                </a:solidFill>
+                <a:effectLst/>
+                <a:uFillTx/>
+                <a:latin typeface="IBM Plex Sans"/>
+              </a:rPr>
+              <a:t>의 카메라 </a:t>
+            </a:r>
+            <a:r>
+              <a:rPr lang="en-US" sz="1300" b="0" u="none" strike="noStrike">
+                <a:solidFill>
+                  <a:srgbClr val="C6C6C6"/>
+                </a:solidFill>
+                <a:effectLst/>
+                <a:uFillTx/>
+                <a:latin typeface="IBM Plex Sans"/>
+              </a:rPr>
+              <a:t>forward </a:t>
+            </a:r>
+            <a:r>
+              <a:rPr lang="zh-CN" sz="1300" b="0" u="none" strike="noStrike">
+                <a:solidFill>
+                  <a:srgbClr val="C6C6C6"/>
+                </a:solidFill>
+                <a:effectLst/>
+                <a:uFillTx/>
+                <a:latin typeface="IBM Plex Sans"/>
+              </a:rPr>
+              <a:t>축 불일치를 보정하여 </a:t>
+            </a:r>
+            <a:r>
+              <a:rPr lang="en-US" sz="1300" b="0" u="none" strike="noStrike">
+                <a:solidFill>
+                  <a:srgbClr val="C6C6C6"/>
+                </a:solidFill>
+                <a:effectLst/>
+                <a:uFillTx/>
+                <a:latin typeface="IBM Plex Sans"/>
+              </a:rPr>
+              <a:t>(`camera.yaw = pi/2 - panel.yaw`) </a:t>
+            </a:r>
+            <a:r>
+              <a:rPr lang="zh-CN" sz="1300" b="0" u="none" strike="noStrike">
+                <a:solidFill>
+                  <a:srgbClr val="C6C6C6"/>
+                </a:solidFill>
+                <a:effectLst/>
+                <a:uFillTx/>
+                <a:latin typeface="IBM Plex Sans"/>
+              </a:rPr>
+              <a:t>정확한 시선 일치 성공</a:t>
+            </a:r>
+            <a:r>
+              <a:rPr lang="en-US" sz="1300" b="0" u="none" strike="noStrike">
+                <a:solidFill>
+                  <a:srgbClr val="C6C6C6"/>
+                </a:solidFill>
+                <a:effectLst/>
+                <a:uFillTx/>
+                <a:latin typeface="IBM Plex Sans"/>
+              </a:rPr>
+              <a:t>.</a:t>
+            </a:r>
+            <a:endParaRPr lang="en-US" sz="1300" b="0" u="none" strike="noStrike">
+              <a:solidFill>
+                <a:srgbClr val="000000"/>
+              </a:solidFill>
+              <a:effectLst/>
+              <a:uFillTx/>
+              <a:latin typeface="Arial"/>
+            </a:endParaRPr>
+          </a:p>
+        </p:txBody>
+      </p:sp>
+      <p:sp>
+        <p:nvSpPr>
+          <p:cNvPr id="143" name="Rectangle 8"/>
+          <p:cNvSpPr/>
+          <p:nvPr/>
+        </p:nvSpPr>
+        <p:spPr>
+          <a:xfrm>
+            <a:off x="6309360" y="1554480"/>
+            <a:ext cx="5120280" cy="4571640"/>
+          </a:xfrm>
+          <a:prstGeom prst="rect">
+            <a:avLst/>
+          </a:prstGeom>
+          <a:solidFill>
+            <a:srgbClr val="262626"/>
+          </a:solidFill>
+          <a:ln w="12700">
+            <a:solidFill>
+              <a:srgbClr val="393939"/>
+            </a:solidFill>
+            <a:round/>
+          </a:ln>
+          <a:effectLst>
+            <a:outerShdw blurRad="39960" dir="5400000" dist="23040" rotWithShape="0">
+              <a:srgbClr val="000000">
+                <a:alpha val="35000"/>
+              </a:srgbClr>
+            </a:outerShdw>
+          </a:effectLst>
+        </p:spPr>
+        <p:style>
+          <a:lnRef idx="1">
+            <a:schemeClr val="accent1"/>
+          </a:lnRef>
+          <a:fillRef idx="3">
+            <a:schemeClr val="accent1"/>
+          </a:fillRef>
+          <a:effectRef idx="2">
+            <a:schemeClr val="accent1"/>
+          </a:effectRef>
+          <a:fontRef idx="minor"/>
+        </p:style>
+        <p:txBody>
+          <a:bodyPr lIns="90000" tIns="45000" rIns="90000" bIns="45000" anchor="ctr">
+            <a:noAutofit/>
+          </a:bodyPr>
+          <a:p>
+            <a:endParaRPr lang="en-US" sz="1800" b="0" u="none" strike="noStrike">
+              <a:solidFill>
+                <a:schemeClr val="lt1"/>
+              </a:solidFill>
+              <a:effectLst/>
+              <a:uFillTx/>
+              <a:latin typeface="Calibri"/>
+            </a:endParaRPr>
+          </a:p>
+        </p:txBody>
+      </p:sp>
+      <p:sp>
+        <p:nvSpPr>
+          <p:cNvPr id="144" name="Rectangle 9"/>
+          <p:cNvSpPr/>
+          <p:nvPr/>
+        </p:nvSpPr>
+        <p:spPr>
+          <a:xfrm>
+            <a:off x="6309360" y="1554480"/>
+            <a:ext cx="72720" cy="4571640"/>
+          </a:xfrm>
+          <a:prstGeom prst="rect">
+            <a:avLst/>
+          </a:prstGeom>
+          <a:solidFill>
+            <a:srgbClr val="393939"/>
+          </a:solidFill>
+          <a:ln>
+            <a:noFill/>
+          </a:ln>
+          <a:effectLst>
+            <a:outerShdw blurRad="39960" dir="5400000" dist="23040" rotWithShape="0">
+              <a:srgbClr val="000000">
+                <a:alpha val="35000"/>
+              </a:srgbClr>
+            </a:outerShdw>
+          </a:effectLst>
+        </p:spPr>
+        <p:style>
+          <a:lnRef idx="1">
+            <a:schemeClr val="accent1"/>
+          </a:lnRef>
+          <a:fillRef idx="3">
+            <a:schemeClr val="accent1"/>
+          </a:fillRef>
+          <a:effectRef idx="2">
+            <a:schemeClr val="accent1"/>
+          </a:effectRef>
+          <a:fontRef idx="minor"/>
+        </p:style>
+        <p:txBody>
+          <a:bodyPr lIns="90000" tIns="45000" rIns="90000" bIns="45000" anchor="ctr">
+            <a:noAutofit/>
+          </a:bodyPr>
+          <a:p>
+            <a:endParaRPr lang="en-US" sz="1800" b="0" u="none" strike="noStrike">
+              <a:solidFill>
+                <a:schemeClr val="lt1"/>
+              </a:solidFill>
+              <a:effectLst/>
+              <a:uFillTx/>
+              <a:latin typeface="Calibri"/>
+            </a:endParaRPr>
+          </a:p>
+        </p:txBody>
+      </p:sp>
+      <p:pic>
+        <p:nvPicPr>
+          <p:cNvPr id="145" name="Picture 10" descr="최종_Edge_textured_3D_map_desktop.jpeg"/>
+          <p:cNvPicPr/>
+          <p:nvPr/>
+        </p:nvPicPr>
+        <p:blipFill>
+          <a:blip r:embed="rId1"/>
+          <a:stretch/>
+        </p:blipFill>
+        <p:spPr>
+          <a:xfrm>
+            <a:off x="6492240" y="1737360"/>
+            <a:ext cx="4754520" cy="3474360"/>
+          </a:xfrm>
+          <a:prstGeom prst="rect">
+            <a:avLst/>
+          </a:prstGeom>
+          <a:noFill/>
+          <a:ln w="0">
+            <a:noFill/>
+          </a:ln>
+        </p:spPr>
+      </p:pic>
+      <p:sp>
+        <p:nvSpPr>
+          <p:cNvPr id="146" name="TextBox 11"/>
+          <p:cNvSpPr/>
+          <p:nvPr/>
+        </p:nvSpPr>
+        <p:spPr>
+          <a:xfrm>
+            <a:off x="6492240" y="5303520"/>
+            <a:ext cx="4754520" cy="731160"/>
+          </a:xfrm>
+          <a:prstGeom prst="rect">
+            <a:avLst/>
+          </a:prstGeom>
+          <a:noFill/>
+          <a:ln w="0">
+            <a:noFill/>
+          </a:ln>
+        </p:spPr>
+        <p:style>
+          <a:lnRef idx="0"/>
+          <a:fillRef idx="0"/>
+          <a:effectRef idx="0"/>
+          <a:fontRef idx="minor"/>
+        </p:style>
+        <p:txBody>
+          <a:bodyPr lIns="0" tIns="0" rIns="0" bIns="0" anchor="t">
+            <a:spAutoFit/>
+          </a:bodyPr>
+          <a:p>
+            <a:pPr defTabSz="457200">
+              <a:lnSpc>
+                <a:spcPct val="100000"/>
+              </a:lnSpc>
+            </a:pPr>
+            <a:r>
+              <a:rPr lang="en-US" sz="1100" b="0" u="none" strike="noStrike">
+                <a:solidFill>
+                  <a:srgbClr val="8D8D8D"/>
+                </a:solidFill>
+                <a:effectLst/>
+                <a:uFillTx/>
+                <a:latin typeface="IBM Plex Sans"/>
+              </a:rPr>
+              <a:t>▲ 최종 완성된 </a:t>
+            </a:r>
+            <a:r>
+              <a:rPr lang="en-US" sz="1100" b="0" u="none" strike="noStrike">
+                <a:solidFill>
+                  <a:srgbClr val="8D8D8D"/>
+                </a:solidFill>
+                <a:effectLst/>
+                <a:uFillTx/>
+                <a:latin typeface="IBM Plex Sans"/>
+              </a:rPr>
+              <a:t>Edge-textured 3D map WebGL </a:t>
+            </a:r>
+            <a:r>
+              <a:rPr lang="zh-CN" sz="1100" b="0" u="none" strike="noStrike">
+                <a:solidFill>
+                  <a:srgbClr val="8D8D8D"/>
+                </a:solidFill>
+                <a:effectLst/>
+                <a:uFillTx/>
+                <a:latin typeface="IBM Plex Sans"/>
+              </a:rPr>
+              <a:t>뷰어 </a:t>
+            </a:r>
+            <a:r>
+              <a:rPr lang="en-US" sz="1100" b="0" u="none" strike="noStrike">
+                <a:solidFill>
+                  <a:srgbClr val="8D8D8D"/>
+                </a:solidFill>
+                <a:effectLst/>
+                <a:uFillTx/>
+                <a:latin typeface="IBM Plex Sans"/>
+              </a:rPr>
+              <a:t>PC </a:t>
+            </a:r>
+            <a:r>
+              <a:rPr lang="zh-CN" sz="1100" b="0" u="none" strike="noStrike">
+                <a:solidFill>
+                  <a:srgbClr val="8D8D8D"/>
+                </a:solidFill>
+                <a:effectLst/>
+                <a:uFillTx/>
+                <a:latin typeface="IBM Plex Sans"/>
+              </a:rPr>
+              <a:t>화면</a:t>
+            </a:r>
+            <a:endParaRPr lang="en-US" sz="1100" b="0" u="none" strike="noStrike">
+              <a:solidFill>
+                <a:srgbClr val="000000"/>
+              </a:solidFill>
+              <a:effectLst/>
+              <a:uFillTx/>
+              <a:latin typeface="Arial"/>
+            </a:endParaRPr>
+          </a:p>
+        </p:txBody>
+      </p:sp>
+    </p:spTree>
+  </p:cSld>
+  <mc:AlternateContent>
+    <mc:Choice Requires="p14">
+      <p:transition spd="slow" p14:dur="2000"/>
+    </mc:Choice>
+    <mc:Fallback>
+      <p:transition spd="slow"/>
+    </mc:Fallback>
+  </mc:AlternateContent>
+</p:sld>
+</file>
+
+<file path=ppt/slides/slide11.xml><?xml version="1.0" encoding="utf-8"?>
+<p:sld xmlns:a="http://schemas.openxmlformats.org/drawingml/2006/main" xmlns:p="http://schemas.openxmlformats.org/presentationml/2006/main" xmlns:r="http://schemas.openxmlformats.org/officeDocument/2006/relationships" xmlns:p14="http://schemas.microsoft.com/office/powerpoint/2010/main" xmlns:p15="http://schemas.microsoft.com/office/powerpoint/2012/main" xmlns:mc="http://schemas.openxmlformats.org/markup-compatibility/2006">
+  <p:cSld>
+    <p:spTree>
+      <p:nvGrpSpPr>
+        <p:cNvPr id="1" name=""/>
+        <p:cNvGrpSpPr/>
+        <p:nvPr/>
+      </p:nvGrpSpPr>
+      <p:grpSpPr>
+        <a:xfrm>
+          <a:off x="0" y="0"/>
+          <a:ext cx="0" cy="0"/>
+          <a:chOff x="0" y="0"/>
+          <a:chExt cx="0" cy="0"/>
+        </a:xfrm>
+      </p:grpSpPr>
+      <p:sp>
+        <p:nvSpPr>
           <p:cNvPr id="147" name="Rectangle 1"/>
           <p:cNvSpPr/>
           <p:nvPr/>
@@ -8896,7 +10146,7 @@
 </p:sld>
 </file>
 
-<file path=ppt/slides/slide11.xml><?xml version="1.0" encoding="utf-8"?>
+<file path=ppt/slides/slide12.xml><?xml version="1.0" encoding="utf-8"?>
 <p:sld xmlns:a="http://schemas.openxmlformats.org/drawingml/2006/main" xmlns:p="http://schemas.openxmlformats.org/presentationml/2006/main" xmlns:r="http://schemas.openxmlformats.org/officeDocument/2006/relationships" xmlns:p14="http://schemas.microsoft.com/office/powerpoint/2010/main" xmlns:p15="http://schemas.microsoft.com/office/powerpoint/2012/main" xmlns:mc="http://schemas.openxmlformats.org/markup-compatibility/2006">
   <p:cSld>
     <p:spTree>
@@ -12700,6 +13950,796 @@
 </file>
 
 <file path=ppt/slides/slide5.xml><?xml version="1.0" encoding="utf-8"?>
+<p:sld xmlns:a="http://schemas.openxmlformats.org/drawingml/2006/main" xmlns:p="http://schemas.openxmlformats.org/presentationml/2006/main" xmlns:r="http://schemas.openxmlformats.org/officeDocument/2006/relationships">
+  <p:cSld>
+    <p:spTree>
+      <p:nvGrpSpPr>
+        <p:cNvPr id="1" name=""/>
+        <p:cNvGrpSpPr/>
+        <p:nvPr/>
+      </p:nvGrpSpPr>
+      <p:grpSpPr/>
+      <p:sp>
+        <p:nvSpPr>
+          <p:cNvPr id="2" name="Title 1"/>
+          <p:cNvSpPr>
+            <a:spLocks noGrp="1"/>
+          </p:cNvSpPr>
+          <p:nvPr>
+            <p:ph type="title"/>
+          </p:nvPr>
+        </p:nvSpPr>
+        <p:spPr/>
+        <p:txBody>
+          <a:bodyPr/>
+          <a:lstStyle/>
+          <a:p/>
+        </p:txBody>
+      </p:sp>
+      <p:sp>
+        <p:nvSpPr>
+          <p:cNvPr id="3" name="Text Placeholder 2"/>
+          <p:cNvSpPr>
+            <a:spLocks noGrp="1"/>
+          </p:cNvSpPr>
+          <p:nvPr>
+            <p:ph type="body"/>
+          </p:nvPr>
+        </p:nvSpPr>
+        <p:spPr/>
+        <p:txBody>
+          <a:bodyPr/>
+          <a:lstStyle/>
+          <a:p/>
+        </p:txBody>
+      </p:sp>
+      <p:sp>
+        <p:nvSpPr>
+          <p:cNvPr id="4" name="Text Placeholder 3"/>
+          <p:cNvSpPr>
+            <a:spLocks noGrp="1"/>
+          </p:cNvSpPr>
+          <p:nvPr>
+            <p:ph type="body"/>
+          </p:nvPr>
+        </p:nvSpPr>
+        <p:spPr/>
+        <p:txBody>
+          <a:bodyPr/>
+          <a:lstStyle/>
+          <a:p/>
+        </p:txBody>
+      </p:sp>
+      <p:sp>
+        <p:nvSpPr>
+          <p:cNvPr id="5" name="Text Placeholder 4"/>
+          <p:cNvSpPr>
+            <a:spLocks noGrp="1"/>
+          </p:cNvSpPr>
+          <p:nvPr>
+            <p:ph type="body"/>
+          </p:nvPr>
+        </p:nvSpPr>
+        <p:spPr/>
+        <p:txBody>
+          <a:bodyPr/>
+          <a:lstStyle/>
+          <a:p/>
+        </p:txBody>
+      </p:sp>
+      <p:sp>
+        <p:nvSpPr>
+          <p:cNvPr id="6" name="Text Placeholder 5"/>
+          <p:cNvSpPr>
+            <a:spLocks noGrp="1"/>
+          </p:cNvSpPr>
+          <p:nvPr>
+            <p:ph type="body"/>
+          </p:nvPr>
+        </p:nvSpPr>
+        <p:spPr/>
+        <p:txBody>
+          <a:bodyPr/>
+          <a:lstStyle/>
+          <a:p/>
+        </p:txBody>
+      </p:sp>
+      <p:sp>
+        <p:nvSpPr>
+          <p:cNvPr id="7" name="Rectangle 6"/>
+          <p:cNvSpPr/>
+          <p:nvPr/>
+        </p:nvSpPr>
+        <p:spPr>
+          <a:xfrm>
+            <a:off x="0" y="0"/>
+            <a:ext cx="12191400" cy="6857640"/>
+          </a:xfrm>
+          <a:prstGeom prst="rect">
+            <a:avLst/>
+          </a:prstGeom>
+          <a:solidFill>
+            <a:srgbClr val="161616"/>
+          </a:solidFill>
+          <a:ln>
+            <a:noFill/>
+          </a:ln>
+        </p:spPr>
+        <p:style>
+          <a:lnRef idx="1">
+            <a:schemeClr val="accent1"/>
+          </a:lnRef>
+          <a:fillRef idx="3">
+            <a:schemeClr val="accent1"/>
+          </a:fillRef>
+          <a:effectRef idx="2">
+            <a:schemeClr val="accent1"/>
+          </a:effectRef>
+          <a:fontRef idx="minor">
+            <a:schemeClr val="lt1"/>
+          </a:fontRef>
+        </p:style>
+        <p:txBody>
+          <a:bodyPr rtlCol="0" anchor="ctr"/>
+          <a:lstStyle/>
+          <a:p>
+            <a:pPr algn="ctr"/>
+          </a:p>
+        </p:txBody>
+      </p:sp>
+      <p:sp>
+        <p:nvSpPr>
+          <p:cNvPr id="8" name="TextBox 7"/>
+          <p:cNvSpPr txBox="1"/>
+          <p:nvPr/>
+        </p:nvSpPr>
+        <p:spPr>
+          <a:xfrm>
+            <a:off x="731520" y="365760"/>
+            <a:ext cx="2600000" cy="273960"/>
+          </a:xfrm>
+          <a:prstGeom prst="rect">
+            <a:avLst/>
+          </a:prstGeom>
+          <a:noFill/>
+        </p:spPr>
+        <p:txBody>
+          <a:bodyPr wrap="none" lIns="0" rIns="0" tIns="0" bIns="0">
+            <a:spAutoFit/>
+          </a:bodyPr>
+          <a:lstStyle/>
+          <a:p>
+            <a:pPr algn="l">
+              <a:defRPr sz="1000" b="1">
+                <a:solidFill>
+                  <a:srgbClr val="8D8D8D"/>
+                </a:solidFill>
+                <a:latin typeface="IBM Plex Sans"/>
+              </a:defRPr>
+            </a:pPr>
+            <a:r>
+              <a:t>04 // ROBOT TEAM</a:t>
+            </a:r>
+          </a:p>
+        </p:txBody>
+      </p:sp>
+      <p:sp>
+        <p:nvSpPr>
+          <p:cNvPr id="9" name="TextBox 8"/>
+          <p:cNvSpPr txBox="1"/>
+          <p:nvPr/>
+        </p:nvSpPr>
+        <p:spPr>
+          <a:xfrm>
+            <a:off x="731520" y="594360"/>
+            <a:ext cx="4200000" cy="366120"/>
+          </a:xfrm>
+          <a:prstGeom prst="rect">
+            <a:avLst/>
+          </a:prstGeom>
+          <a:noFill/>
+        </p:spPr>
+        <p:txBody>
+          <a:bodyPr wrap="none" lIns="0" rIns="0" tIns="0" bIns="0">
+            <a:spAutoFit/>
+          </a:bodyPr>
+          <a:lstStyle/>
+          <a:p>
+            <a:pPr algn="l">
+              <a:defRPr sz="3000" b="1">
+                <a:solidFill>
+                  <a:srgbClr val="F5F5F5"/>
+                </a:solidFill>
+                <a:latin typeface="IBM Plex Sans"/>
+              </a:defRPr>
+            </a:pPr>
+            <a:r>
+              <a:t>시뮬레이션 구현</a:t>
+            </a:r>
+          </a:p>
+        </p:txBody>
+      </p:sp>
+      <p:sp>
+        <p:nvSpPr>
+          <p:cNvPr id="10" name="Rectangle 9"/>
+          <p:cNvSpPr/>
+          <p:nvPr/>
+        </p:nvSpPr>
+        <p:spPr>
+          <a:xfrm>
+            <a:off x="731520" y="1188720"/>
+            <a:ext cx="10728360" cy="18000"/>
+          </a:xfrm>
+          <a:prstGeom prst="rect">
+            <a:avLst/>
+          </a:prstGeom>
+          <a:solidFill>
+            <a:srgbClr val="373737"/>
+          </a:solidFill>
+          <a:ln>
+            <a:noFill/>
+          </a:ln>
+        </p:spPr>
+        <p:style>
+          <a:lnRef idx="1">
+            <a:schemeClr val="accent1"/>
+          </a:lnRef>
+          <a:fillRef idx="3">
+            <a:schemeClr val="accent1"/>
+          </a:fillRef>
+          <a:effectRef idx="2">
+            <a:schemeClr val="accent1"/>
+          </a:effectRef>
+          <a:fontRef idx="minor">
+            <a:schemeClr val="lt1"/>
+          </a:fontRef>
+        </p:style>
+        <p:txBody>
+          <a:bodyPr rtlCol="0" anchor="ctr"/>
+          <a:lstStyle/>
+          <a:p>
+            <a:pPr algn="ctr"/>
+          </a:p>
+        </p:txBody>
+      </p:sp>
+      <p:sp>
+        <p:nvSpPr>
+          <p:cNvPr id="11" name="Rectangle 10"/>
+          <p:cNvSpPr/>
+          <p:nvPr/>
+        </p:nvSpPr>
+        <p:spPr>
+          <a:xfrm>
+            <a:off x="731520" y="1554480"/>
+            <a:ext cx="5120280" cy="4571640"/>
+          </a:xfrm>
+          <a:prstGeom prst="rect">
+            <a:avLst/>
+          </a:prstGeom>
+          <a:solidFill>
+            <a:srgbClr val="242424"/>
+          </a:solidFill>
+          <a:ln w="12700">
+            <a:solidFill>
+              <a:srgbClr val="414141"/>
+            </a:solidFill>
+          </a:ln>
+        </p:spPr>
+        <p:style>
+          <a:lnRef idx="1">
+            <a:schemeClr val="accent1"/>
+          </a:lnRef>
+          <a:fillRef idx="3">
+            <a:schemeClr val="accent1"/>
+          </a:fillRef>
+          <a:effectRef idx="2">
+            <a:schemeClr val="accent1"/>
+          </a:effectRef>
+          <a:fontRef idx="minor">
+            <a:schemeClr val="lt1"/>
+          </a:fontRef>
+        </p:style>
+        <p:txBody>
+          <a:bodyPr rtlCol="0" anchor="ctr"/>
+          <a:lstStyle/>
+          <a:p>
+            <a:pPr algn="ctr"/>
+          </a:p>
+        </p:txBody>
+      </p:sp>
+      <p:sp>
+        <p:nvSpPr>
+          <p:cNvPr id="12" name="Rectangle 11"/>
+          <p:cNvSpPr/>
+          <p:nvPr/>
+        </p:nvSpPr>
+        <p:spPr>
+          <a:xfrm>
+            <a:off x="731520" y="1554480"/>
+            <a:ext cx="72720" cy="4571640"/>
+          </a:xfrm>
+          <a:prstGeom prst="rect">
+            <a:avLst/>
+          </a:prstGeom>
+          <a:solidFill>
+            <a:srgbClr val="2A9FFF"/>
+          </a:solidFill>
+          <a:ln>
+            <a:noFill/>
+          </a:ln>
+        </p:spPr>
+        <p:style>
+          <a:lnRef idx="1">
+            <a:schemeClr val="accent1"/>
+          </a:lnRef>
+          <a:fillRef idx="3">
+            <a:schemeClr val="accent1"/>
+          </a:fillRef>
+          <a:effectRef idx="2">
+            <a:schemeClr val="accent1"/>
+          </a:effectRef>
+          <a:fontRef idx="minor">
+            <a:schemeClr val="lt1"/>
+          </a:fontRef>
+        </p:style>
+        <p:txBody>
+          <a:bodyPr rtlCol="0" anchor="ctr"/>
+          <a:lstStyle/>
+          <a:p>
+            <a:pPr algn="ctr"/>
+          </a:p>
+        </p:txBody>
+      </p:sp>
+      <p:sp>
+        <p:nvSpPr>
+          <p:cNvPr id="13" name="Rectangle 12"/>
+          <p:cNvSpPr/>
+          <p:nvPr/>
+        </p:nvSpPr>
+        <p:spPr>
+          <a:xfrm>
+            <a:off x="6309360" y="1554480"/>
+            <a:ext cx="5120280" cy="4571640"/>
+          </a:xfrm>
+          <a:prstGeom prst="rect">
+            <a:avLst/>
+          </a:prstGeom>
+          <a:solidFill>
+            <a:srgbClr val="242424"/>
+          </a:solidFill>
+          <a:ln w="12700">
+            <a:solidFill>
+              <a:srgbClr val="414141"/>
+            </a:solidFill>
+          </a:ln>
+        </p:spPr>
+        <p:style>
+          <a:lnRef idx="1">
+            <a:schemeClr val="accent1"/>
+          </a:lnRef>
+          <a:fillRef idx="3">
+            <a:schemeClr val="accent1"/>
+          </a:fillRef>
+          <a:effectRef idx="2">
+            <a:schemeClr val="accent1"/>
+          </a:effectRef>
+          <a:fontRef idx="minor">
+            <a:schemeClr val="lt1"/>
+          </a:fontRef>
+        </p:style>
+        <p:txBody>
+          <a:bodyPr rtlCol="0" anchor="ctr"/>
+          <a:lstStyle/>
+          <a:p>
+            <a:pPr algn="ctr"/>
+          </a:p>
+        </p:txBody>
+      </p:sp>
+      <p:sp>
+        <p:nvSpPr>
+          <p:cNvPr id="14" name="Rectangle 13"/>
+          <p:cNvSpPr/>
+          <p:nvPr/>
+        </p:nvSpPr>
+        <p:spPr>
+          <a:xfrm>
+            <a:off x="6309360" y="1554480"/>
+            <a:ext cx="72720" cy="4571640"/>
+          </a:xfrm>
+          <a:prstGeom prst="rect">
+            <a:avLst/>
+          </a:prstGeom>
+          <a:solidFill>
+            <a:srgbClr val="3A3A3A"/>
+          </a:solidFill>
+          <a:ln>
+            <a:noFill/>
+          </a:ln>
+        </p:spPr>
+        <p:style>
+          <a:lnRef idx="1">
+            <a:schemeClr val="accent1"/>
+          </a:lnRef>
+          <a:fillRef idx="3">
+            <a:schemeClr val="accent1"/>
+          </a:fillRef>
+          <a:effectRef idx="2">
+            <a:schemeClr val="accent1"/>
+          </a:effectRef>
+          <a:fontRef idx="minor">
+            <a:schemeClr val="lt1"/>
+          </a:fontRef>
+        </p:style>
+        <p:txBody>
+          <a:bodyPr rtlCol="0" anchor="ctr"/>
+          <a:lstStyle/>
+          <a:p>
+            <a:pPr algn="ctr"/>
+          </a:p>
+        </p:txBody>
+      </p:sp>
+      <p:sp>
+        <p:nvSpPr>
+          <p:cNvPr id="15" name="TextBox 14"/>
+          <p:cNvSpPr txBox="1"/>
+          <p:nvPr/>
+        </p:nvSpPr>
+        <p:spPr>
+          <a:xfrm>
+            <a:off x="1005840" y="1690000"/>
+            <a:ext cx="4440000" cy="3320000"/>
+          </a:xfrm>
+          <a:prstGeom prst="rect">
+            <a:avLst/>
+          </a:prstGeom>
+          <a:noFill/>
+        </p:spPr>
+        <p:txBody>
+          <a:bodyPr wrap="square" lIns="0" rIns="0" tIns="0" bIns="0">
+            <a:spAutoFit/>
+          </a:bodyPr>
+          <a:lstStyle/>
+          <a:p>
+            <a:pPr>
+              <a:spcAft>
+                <a:spcPts val="1000"/>
+              </a:spcAft>
+              <a:defRPr sz="1500" b="1">
+                <a:solidFill>
+                  <a:srgbClr val="2A9FFF"/>
+                </a:solidFill>
+                <a:latin typeface="IBM Plex Sans"/>
+              </a:defRPr>
+            </a:pPr>
+            <a:r>
+              <a:t>SIMULATION DUAL-CAMERA STACK</a:t>
+            </a:r>
+          </a:p>
+          <a:p>
+            <a:pPr>
+              <a:lnSpc>
+                <a:spcPct val="105000"/>
+              </a:lnSpc>
+              <a:spcAft>
+                <a:spcPts val="600"/>
+              </a:spcAft>
+              <a:defRPr sz="1500">
+                <a:solidFill>
+                  <a:srgbClr val="EBEBEB"/>
+                </a:solidFill>
+                <a:latin typeface="IBM Plex Sans"/>
+              </a:defRPr>
+            </a:pPr>
+            <a:r>
+              <a:t>Gazebo Sim에 TurtleBot3 Burger + C920/C270 카메라 모델 구성</a:t>
+            </a:r>
+          </a:p>
+          <a:p>
+            <a:pPr>
+              <a:lnSpc>
+                <a:spcPct val="105000"/>
+              </a:lnSpc>
+              <a:spcAft>
+                <a:spcPts val="600"/>
+              </a:spcAft>
+              <a:defRPr sz="1500">
+                <a:solidFill>
+                  <a:srgbClr val="EBEBEB"/>
+                </a:solidFill>
+                <a:latin typeface="IBM Plex Sans"/>
+              </a:defRPr>
+            </a:pPr>
+            <a:r>
+              <a:t>URDF/SDF에 camera link와 optical frame을 추가해 TF 구조 정렬</a:t>
+            </a:r>
+          </a:p>
+          <a:p>
+            <a:pPr>
+              <a:lnSpc>
+                <a:spcPct val="105000"/>
+              </a:lnSpc>
+              <a:spcAft>
+                <a:spcPts val="600"/>
+              </a:spcAft>
+              <a:defRPr sz="1500">
+                <a:solidFill>
+                  <a:srgbClr val="EBEBEB"/>
+                </a:solidFill>
+                <a:latin typeface="IBM Plex Sans"/>
+              </a:defRPr>
+            </a:pPr>
+            <a:r>
+              <a:t>ros_gz_bridge / ros_gz_image로 두 카메라 image_raw와 camera_info 노출</a:t>
+            </a:r>
+          </a:p>
+          <a:p>
+            <a:pPr>
+              <a:lnSpc>
+                <a:spcPct val="105000"/>
+              </a:lnSpc>
+              <a:spcAft>
+                <a:spcPts val="600"/>
+              </a:spcAft>
+              <a:defRPr sz="1500">
+                <a:solidFill>
+                  <a:srgbClr val="EBEBEB"/>
+                </a:solidFill>
+                <a:latin typeface="IBM Plex Sans"/>
+              </a:defRPr>
+            </a:pPr>
+            <a:r>
+              <a:t>RViz2에서 robot model, LaserScan, TF, dual camera image panel 동시 검증</a:t>
+            </a:r>
+          </a:p>
+          <a:p>
+            <a:pPr>
+              <a:lnSpc>
+                <a:spcPct val="105000"/>
+              </a:lnSpc>
+              <a:spcAft>
+                <a:spcPts val="600"/>
+              </a:spcAft>
+              <a:defRPr sz="1500">
+                <a:solidFill>
+                  <a:srgbClr val="EBEBEB"/>
+                </a:solidFill>
+                <a:latin typeface="IBM Plex Sans"/>
+              </a:defRPr>
+            </a:pPr>
+            <a:r>
+              <a:t>실물 로봇과 같은 토픽/프레임 이름으로 bag 및 비전 handoff 계약 유지</a:t>
+            </a:r>
+          </a:p>
+        </p:txBody>
+      </p:sp>
+      <p:sp>
+        <p:nvSpPr>
+          <p:cNvPr id="16" name="Rounded Rectangle 15"/>
+          <p:cNvSpPr/>
+          <p:nvPr/>
+        </p:nvSpPr>
+        <p:spPr>
+          <a:xfrm>
+            <a:off x="1005840" y="5300000"/>
+            <a:ext cx="4240000" cy="620000"/>
+          </a:xfrm>
+          <a:prstGeom prst="roundRect">
+            <a:avLst/>
+          </a:prstGeom>
+          <a:solidFill>
+            <a:srgbClr val="222222"/>
+          </a:solidFill>
+          <a:ln w="15240">
+            <a:solidFill>
+              <a:srgbClr val="2A9FFF"/>
+            </a:solidFill>
+          </a:ln>
+        </p:spPr>
+        <p:style>
+          <a:lnRef idx="1">
+            <a:schemeClr val="accent1"/>
+          </a:lnRef>
+          <a:fillRef idx="3">
+            <a:schemeClr val="accent1"/>
+          </a:fillRef>
+          <a:effectRef idx="2">
+            <a:schemeClr val="accent1"/>
+          </a:effectRef>
+          <a:fontRef idx="minor">
+            <a:schemeClr val="lt1"/>
+          </a:fontRef>
+        </p:style>
+        <p:txBody>
+          <a:bodyPr rtlCol="0" anchor="ctr" lIns="150000" rIns="150000" tIns="55000"/>
+          <a:lstStyle/>
+          <a:p>
+            <a:pPr algn="ctr">
+              <a:defRPr sz="1200" b="1">
+                <a:solidFill>
+                  <a:srgbClr val="DCDCDC"/>
+                </a:solidFill>
+                <a:latin typeface="IBM Plex Sans"/>
+              </a:defRPr>
+            </a:pPr>
+            <a:r>
+              <a:t>SIMULATION  |  dual camera topics verified before real-robot recording</a:t>
+            </a:r>
+          </a:p>
+        </p:txBody>
+      </p:sp>
+      <p:pic>
+        <p:nvPicPr>
+          <p:cNvPr id="17" name="Picture 16" descr="sim_gazebo_wide.jpg"/>
+          <p:cNvPicPr>
+            <a:picLocks noChangeAspect="1"/>
+          </p:cNvPicPr>
+          <p:nvPr/>
+        </p:nvPicPr>
+        <p:blipFill>
+          <a:blip r:embed="rId2"/>
+          <a:stretch>
+            <a:fillRect/>
+          </a:stretch>
+        </p:blipFill>
+        <p:spPr>
+          <a:xfrm>
+            <a:off x="6539360" y="1854480"/>
+            <a:ext cx="4660280" cy="1850000"/>
+          </a:xfrm>
+          <a:prstGeom prst="rect">
+            <a:avLst/>
+          </a:prstGeom>
+          <a:ln w="12700">
+            <a:solidFill>
+              <a:srgbClr val="414141"/>
+            </a:solidFill>
+          </a:ln>
+        </p:spPr>
+      </p:pic>
+      <p:pic>
+        <p:nvPicPr>
+          <p:cNvPr id="18" name="Picture 17" descr="sim_rviz_wide.jpg"/>
+          <p:cNvPicPr>
+            <a:picLocks noChangeAspect="1"/>
+          </p:cNvPicPr>
+          <p:nvPr/>
+        </p:nvPicPr>
+        <p:blipFill>
+          <a:blip r:embed="rId3"/>
+          <a:stretch>
+            <a:fillRect/>
+          </a:stretch>
+        </p:blipFill>
+        <p:spPr>
+          <a:xfrm>
+            <a:off x="6539360" y="4114480"/>
+            <a:ext cx="4660280" cy="1850000"/>
+          </a:xfrm>
+          <a:prstGeom prst="rect">
+            <a:avLst/>
+          </a:prstGeom>
+          <a:ln w="12700">
+            <a:solidFill>
+              <a:srgbClr val="414141"/>
+            </a:solidFill>
+          </a:ln>
+        </p:spPr>
+      </p:pic>
+      <p:sp>
+        <p:nvSpPr>
+          <p:cNvPr id="19" name="Rectangle 18"/>
+          <p:cNvSpPr/>
+          <p:nvPr/>
+        </p:nvSpPr>
+        <p:spPr>
+          <a:xfrm>
+            <a:off x="6539360" y="3464480"/>
+            <a:ext cx="4660280" cy="240000"/>
+          </a:xfrm>
+          <a:prstGeom prst="rect">
+            <a:avLst/>
+          </a:prstGeom>
+          <a:solidFill>
+            <a:srgbClr val="161616"/>
+          </a:solidFill>
+          <a:ln>
+            <a:noFill/>
+          </a:ln>
+        </p:spPr>
+        <p:style>
+          <a:lnRef idx="1">
+            <a:schemeClr val="accent1"/>
+          </a:lnRef>
+          <a:fillRef idx="3">
+            <a:schemeClr val="accent1"/>
+          </a:fillRef>
+          <a:effectRef idx="2">
+            <a:schemeClr val="accent1"/>
+          </a:effectRef>
+          <a:fontRef idx="minor">
+            <a:schemeClr val="lt1"/>
+          </a:fontRef>
+        </p:style>
+        <p:txBody>
+          <a:bodyPr rtlCol="0" anchor="ctr" wrap="square" lIns="70000" rIns="70000" tIns="15000"/>
+          <a:lstStyle/>
+          <a:p>
+            <a:pPr algn="ctr">
+              <a:defRPr sz="850" b="1">
+                <a:solidFill>
+                  <a:srgbClr val="DADADA"/>
+                </a:solidFill>
+                <a:latin typeface="IBM Plex Sans"/>
+              </a:defRPr>
+            </a:pPr>
+            <a:r>
+              <a:t>GAZEBO SIM  |  TurtleBot3 Burger model with C920 / C270 camera sensors</a:t>
+            </a:r>
+          </a:p>
+        </p:txBody>
+      </p:sp>
+      <p:sp>
+        <p:nvSpPr>
+          <p:cNvPr id="20" name="Rectangle 19"/>
+          <p:cNvSpPr/>
+          <p:nvPr/>
+        </p:nvSpPr>
+        <p:spPr>
+          <a:xfrm>
+            <a:off x="6539360" y="5724480"/>
+            <a:ext cx="4660280" cy="240000"/>
+          </a:xfrm>
+          <a:prstGeom prst="rect">
+            <a:avLst/>
+          </a:prstGeom>
+          <a:solidFill>
+            <a:srgbClr val="161616"/>
+          </a:solidFill>
+          <a:ln>
+            <a:noFill/>
+          </a:ln>
+        </p:spPr>
+        <p:style>
+          <a:lnRef idx="1">
+            <a:schemeClr val="accent1"/>
+          </a:lnRef>
+          <a:fillRef idx="3">
+            <a:schemeClr val="accent1"/>
+          </a:fillRef>
+          <a:effectRef idx="2">
+            <a:schemeClr val="accent1"/>
+          </a:effectRef>
+          <a:fontRef idx="minor">
+            <a:schemeClr val="lt1"/>
+          </a:fontRef>
+        </p:style>
+        <p:txBody>
+          <a:bodyPr rtlCol="0" anchor="ctr" wrap="square" lIns="70000" rIns="70000" tIns="15000"/>
+          <a:lstStyle/>
+          <a:p>
+            <a:pPr algn="ctr">
+              <a:defRPr sz="850" b="1">
+                <a:solidFill>
+                  <a:srgbClr val="DADADA"/>
+                </a:solidFill>
+                <a:latin typeface="IBM Plex Sans"/>
+              </a:defRPr>
+            </a:pPr>
+            <a:r>
+              <a:t>RVIZ2 CHECK  |  TF, LaserScan, robot model, and dual camera streams</a:t>
+            </a:r>
+          </a:p>
+        </p:txBody>
+      </p:sp>
+    </p:spTree>
+  </p:cSld>
+  <p:clrMapOvr>
+    <a:masterClrMapping/>
+  </p:clrMapOvr>
+</p:sld>
+</file>
+
+<file path=ppt/slides/slide6.xml><?xml version="1.0" encoding="utf-8"?>
 <p:sld xmlns:a="http://schemas.openxmlformats.org/drawingml/2006/main" xmlns:p="http://schemas.openxmlformats.org/presentationml/2006/main" xmlns:r="http://schemas.openxmlformats.org/officeDocument/2006/relationships" xmlns:p14="http://schemas.microsoft.com/office/powerpoint/2010/main" xmlns:p15="http://schemas.microsoft.com/office/powerpoint/2012/main" xmlns:mc="http://schemas.openxmlformats.org/markup-compatibility/2006">
   <p:cSld>
     <p:spTree>
@@ -13209,7 +15249,7 @@
 </p:sld>
 </file>
 
-<file path=ppt/slides/slide6.xml><?xml version="1.0" encoding="utf-8"?>
+<file path=ppt/slides/slide7.xml><?xml version="1.0" encoding="utf-8"?>
 <p:sld xmlns:a="http://schemas.openxmlformats.org/drawingml/2006/main" xmlns:p="http://schemas.openxmlformats.org/presentationml/2006/main" xmlns:r="http://schemas.openxmlformats.org/officeDocument/2006/relationships" xmlns:p14="http://schemas.microsoft.com/office/powerpoint/2010/main" xmlns:p15="http://schemas.microsoft.com/office/powerpoint/2012/main" xmlns:mc="http://schemas.openxmlformats.org/markup-compatibility/2006">
   <p:cSld>
     <p:spTree>
@@ -14407,7 +16447,7 @@
 </p:sld>
 </file>
 
-<file path=ppt/slides/slide7.xml><?xml version="1.0" encoding="utf-8"?>
+<file path=ppt/slides/slide8.xml><?xml version="1.0" encoding="utf-8"?>
 <p:sld xmlns:a="http://schemas.openxmlformats.org/drawingml/2006/main" xmlns:p="http://schemas.openxmlformats.org/presentationml/2006/main" xmlns:r="http://schemas.openxmlformats.org/officeDocument/2006/relationships" xmlns:p14="http://schemas.microsoft.com/office/powerpoint/2010/main" xmlns:p15="http://schemas.microsoft.com/office/powerpoint/2012/main" xmlns:mc="http://schemas.openxmlformats.org/markup-compatibility/2006">
   <p:cSld>
     <p:spTree>
@@ -15674,7 +17714,7 @@
 </p:sld>
 </file>
 
-<file path=ppt/slides/slide8.xml><?xml version="1.0" encoding="utf-8"?>
+<file path=ppt/slides/slide9.xml><?xml version="1.0" encoding="utf-8"?>
 <p:sld xmlns:a="http://schemas.openxmlformats.org/drawingml/2006/main" xmlns:p="http://schemas.openxmlformats.org/presentationml/2006/main" xmlns:r="http://schemas.openxmlformats.org/officeDocument/2006/relationships" xmlns:p14="http://schemas.microsoft.com/office/powerpoint/2010/main" xmlns:p15="http://schemas.microsoft.com/office/powerpoint/2012/main" xmlns:mc="http://schemas.openxmlformats.org/markup-compatibility/2006">
   <p:cSld>
     <p:spTree>
@@ -16788,1255 +18828,6 @@
                 <a:latin typeface="IBM Plex Sans"/>
               </a:rPr>
               <a:t>시뮬레이션 화면</a:t>
-            </a:r>
-            <a:endParaRPr lang="en-US" sz="1100" b="0" u="none" strike="noStrike">
-              <a:solidFill>
-                <a:srgbClr val="000000"/>
-              </a:solidFill>
-              <a:effectLst/>
-              <a:uFillTx/>
-              <a:latin typeface="Arial"/>
-            </a:endParaRPr>
-          </a:p>
-        </p:txBody>
-      </p:sp>
-    </p:spTree>
-  </p:cSld>
-  <mc:AlternateContent>
-    <mc:Choice Requires="p14">
-      <p:transition spd="slow" p14:dur="2000"/>
-    </mc:Choice>
-    <mc:Fallback>
-      <p:transition spd="slow"/>
-    </mc:Fallback>
-  </mc:AlternateContent>
-</p:sld>
-</file>
-
-<file path=ppt/slides/slide9.xml><?xml version="1.0" encoding="utf-8"?>
-<p:sld xmlns:a="http://schemas.openxmlformats.org/drawingml/2006/main" xmlns:p="http://schemas.openxmlformats.org/presentationml/2006/main" xmlns:r="http://schemas.openxmlformats.org/officeDocument/2006/relationships" xmlns:p14="http://schemas.microsoft.com/office/powerpoint/2010/main" xmlns:p15="http://schemas.microsoft.com/office/powerpoint/2012/main" xmlns:mc="http://schemas.openxmlformats.org/markup-compatibility/2006">
-  <p:cSld>
-    <p:spTree>
-      <p:nvGrpSpPr>
-        <p:cNvPr id="1" name=""/>
-        <p:cNvGrpSpPr/>
-        <p:nvPr/>
-      </p:nvGrpSpPr>
-      <p:grpSpPr>
-        <a:xfrm>
-          <a:off x="0" y="0"/>
-          <a:ext cx="0" cy="0"/>
-          <a:chOff x="0" y="0"/>
-          <a:chExt cx="0" cy="0"/>
-        </a:xfrm>
-      </p:grpSpPr>
-      <p:sp>
-        <p:nvSpPr>
-          <p:cNvPr id="136" name="Rectangle 1"/>
-          <p:cNvSpPr/>
-          <p:nvPr/>
-        </p:nvSpPr>
-        <p:spPr>
-          <a:xfrm>
-            <a:off x="0" y="0"/>
-            <a:ext cx="12191400" cy="6857640"/>
-          </a:xfrm>
-          <a:prstGeom prst="rect">
-            <a:avLst/>
-          </a:prstGeom>
-          <a:solidFill>
-            <a:srgbClr val="161616"/>
-          </a:solidFill>
-          <a:ln>
-            <a:noFill/>
-          </a:ln>
-          <a:effectLst>
-            <a:outerShdw blurRad="39960" dir="5400000" dist="23040" rotWithShape="0">
-              <a:srgbClr val="000000">
-                <a:alpha val="35000"/>
-              </a:srgbClr>
-            </a:outerShdw>
-          </a:effectLst>
-        </p:spPr>
-        <p:style>
-          <a:lnRef idx="1">
-            <a:schemeClr val="accent1"/>
-          </a:lnRef>
-          <a:fillRef idx="3">
-            <a:schemeClr val="accent1"/>
-          </a:fillRef>
-          <a:effectRef idx="2">
-            <a:schemeClr val="accent1"/>
-          </a:effectRef>
-          <a:fontRef idx="minor"/>
-        </p:style>
-        <p:txBody>
-          <a:bodyPr lIns="90000" tIns="45000" rIns="90000" bIns="45000" anchor="ctr">
-            <a:noAutofit/>
-          </a:bodyPr>
-          <a:p>
-            <a:endParaRPr lang="en-US" sz="1800" b="0" u="none" strike="noStrike">
-              <a:solidFill>
-                <a:schemeClr val="lt1"/>
-              </a:solidFill>
-              <a:effectLst/>
-              <a:uFillTx/>
-              <a:latin typeface="Calibri"/>
-            </a:endParaRPr>
-          </a:p>
-        </p:txBody>
-      </p:sp>
-      <p:sp>
-        <p:nvSpPr>
-          <p:cNvPr id="137" name="TextBox 2"/>
-          <p:cNvSpPr/>
-          <p:nvPr/>
-        </p:nvSpPr>
-        <p:spPr>
-          <a:xfrm>
-            <a:off x="731520" y="365760"/>
-            <a:ext cx="10728360" cy="273960"/>
-          </a:xfrm>
-          <a:prstGeom prst="rect">
-            <a:avLst/>
-          </a:prstGeom>
-          <a:noFill/>
-          <a:ln w="0">
-            <a:noFill/>
-          </a:ln>
-        </p:spPr>
-        <p:style>
-          <a:lnRef idx="0"/>
-          <a:fillRef idx="0"/>
-          <a:effectRef idx="0"/>
-          <a:fontRef idx="minor"/>
-        </p:style>
-        <p:txBody>
-          <a:bodyPr lIns="0" tIns="0" rIns="0" bIns="0" anchor="t">
-            <a:spAutoFit/>
-          </a:bodyPr>
-          <a:p>
-            <a:pPr defTabSz="457200">
-              <a:lnSpc>
-                <a:spcPct val="100000"/>
-              </a:lnSpc>
-            </a:pPr>
-            <a:r>
-              <a:rPr lang="en-US" sz="1000" b="1" u="none" strike="noStrike">
-                <a:solidFill>
-                  <a:srgbClr val="8D8D8D"/>
-                </a:solidFill>
-                <a:effectLst/>
-                <a:uFillTx/>
-                <a:latin typeface="IBM Plex Sans"/>
-              </a:rPr>
-              <a:t>07 // FINAL OUTCOME</a:t>
-            </a:r>
-            <a:endParaRPr lang="en-US" sz="1000" b="0" u="none" strike="noStrike">
-              <a:solidFill>
-                <a:srgbClr val="000000"/>
-              </a:solidFill>
-              <a:effectLst/>
-              <a:uFillTx/>
-              <a:latin typeface="Arial"/>
-            </a:endParaRPr>
-          </a:p>
-        </p:txBody>
-      </p:sp>
-      <p:sp>
-        <p:nvSpPr>
-          <p:cNvPr id="138" name="TextBox 3"/>
-          <p:cNvSpPr/>
-          <p:nvPr/>
-        </p:nvSpPr>
-        <p:spPr>
-          <a:xfrm>
-            <a:off x="731520" y="594360"/>
-            <a:ext cx="10728360" cy="366120"/>
-          </a:xfrm>
-          <a:prstGeom prst="rect">
-            <a:avLst/>
-          </a:prstGeom>
-          <a:noFill/>
-          <a:ln w="0">
-            <a:noFill/>
-          </a:ln>
-        </p:spPr>
-        <p:style>
-          <a:lnRef idx="0"/>
-          <a:fillRef idx="0"/>
-          <a:effectRef idx="0"/>
-          <a:fontRef idx="minor"/>
-        </p:style>
-        <p:txBody>
-          <a:bodyPr lIns="0" tIns="0" rIns="0" bIns="0" anchor="t">
-            <a:spAutoFit/>
-          </a:bodyPr>
-          <a:p>
-            <a:pPr defTabSz="457200">
-              <a:lnSpc>
-                <a:spcPct val="100000"/>
-              </a:lnSpc>
-            </a:pPr>
-            <a:r>
-              <a:rPr lang="en-US" sz="2400" b="1" u="none" strike="noStrike">
-                <a:solidFill>
-                  <a:srgbClr val="FFFFFF"/>
-                </a:solidFill>
-                <a:effectLst/>
-                <a:uFillTx/>
-                <a:latin typeface="IBM Plex Sans"/>
-              </a:rPr>
-              <a:t>Edge-Textured True 3D Map</a:t>
-            </a:r>
-            <a:endParaRPr lang="en-US" sz="2400" b="0" u="none" strike="noStrike">
-              <a:solidFill>
-                <a:srgbClr val="000000"/>
-              </a:solidFill>
-              <a:effectLst/>
-              <a:uFillTx/>
-              <a:latin typeface="Arial"/>
-            </a:endParaRPr>
-          </a:p>
-        </p:txBody>
-      </p:sp>
-      <p:sp>
-        <p:nvSpPr>
-          <p:cNvPr id="139" name="Rectangle 4"/>
-          <p:cNvSpPr/>
-          <p:nvPr/>
-        </p:nvSpPr>
-        <p:spPr>
-          <a:xfrm>
-            <a:off x="731520" y="1188720"/>
-            <a:ext cx="10728360" cy="18000"/>
-          </a:xfrm>
-          <a:prstGeom prst="rect">
-            <a:avLst/>
-          </a:prstGeom>
-          <a:solidFill>
-            <a:srgbClr val="393939"/>
-          </a:solidFill>
-          <a:ln>
-            <a:noFill/>
-          </a:ln>
-          <a:effectLst>
-            <a:outerShdw blurRad="39960" dir="5400000" dist="23040" rotWithShape="0">
-              <a:srgbClr val="000000">
-                <a:alpha val="35000"/>
-              </a:srgbClr>
-            </a:outerShdw>
-          </a:effectLst>
-        </p:spPr>
-        <p:style>
-          <a:lnRef idx="1">
-            <a:schemeClr val="accent1"/>
-          </a:lnRef>
-          <a:fillRef idx="3">
-            <a:schemeClr val="accent1"/>
-          </a:fillRef>
-          <a:effectRef idx="2">
-            <a:schemeClr val="accent1"/>
-          </a:effectRef>
-          <a:fontRef idx="minor"/>
-        </p:style>
-        <p:txBody>
-          <a:bodyPr lIns="90000" tIns="-26640" rIns="90000" bIns="-26640" anchor="ctr">
-            <a:noAutofit/>
-          </a:bodyPr>
-          <a:p>
-            <a:endParaRPr lang="en-US" sz="1800" b="0" u="none" strike="noStrike">
-              <a:solidFill>
-                <a:schemeClr val="lt1"/>
-              </a:solidFill>
-              <a:effectLst/>
-              <a:uFillTx/>
-              <a:latin typeface="Calibri"/>
-            </a:endParaRPr>
-          </a:p>
-        </p:txBody>
-      </p:sp>
-      <p:sp>
-        <p:nvSpPr>
-          <p:cNvPr id="140" name="Rectangle 5"/>
-          <p:cNvSpPr/>
-          <p:nvPr/>
-        </p:nvSpPr>
-        <p:spPr>
-          <a:xfrm>
-            <a:off x="731520" y="1554480"/>
-            <a:ext cx="5120280" cy="4571640"/>
-          </a:xfrm>
-          <a:prstGeom prst="rect">
-            <a:avLst/>
-          </a:prstGeom>
-          <a:solidFill>
-            <a:srgbClr val="262626"/>
-          </a:solidFill>
-          <a:ln w="12700">
-            <a:solidFill>
-              <a:srgbClr val="393939"/>
-            </a:solidFill>
-            <a:round/>
-          </a:ln>
-          <a:effectLst>
-            <a:outerShdw blurRad="39960" dir="5400000" dist="23040" rotWithShape="0">
-              <a:srgbClr val="000000">
-                <a:alpha val="35000"/>
-              </a:srgbClr>
-            </a:outerShdw>
-          </a:effectLst>
-        </p:spPr>
-        <p:style>
-          <a:lnRef idx="1">
-            <a:schemeClr val="accent1"/>
-          </a:lnRef>
-          <a:fillRef idx="3">
-            <a:schemeClr val="accent1"/>
-          </a:fillRef>
-          <a:effectRef idx="2">
-            <a:schemeClr val="accent1"/>
-          </a:effectRef>
-          <a:fontRef idx="minor"/>
-        </p:style>
-        <p:txBody>
-          <a:bodyPr lIns="90000" tIns="45000" rIns="90000" bIns="45000" anchor="ctr">
-            <a:noAutofit/>
-          </a:bodyPr>
-          <a:p>
-            <a:endParaRPr lang="en-US" sz="1800" b="0" u="none" strike="noStrike">
-              <a:solidFill>
-                <a:schemeClr val="lt1"/>
-              </a:solidFill>
-              <a:effectLst/>
-              <a:uFillTx/>
-              <a:latin typeface="Calibri"/>
-            </a:endParaRPr>
-          </a:p>
-        </p:txBody>
-      </p:sp>
-      <p:sp>
-        <p:nvSpPr>
-          <p:cNvPr id="141" name="Rectangle 6"/>
-          <p:cNvSpPr/>
-          <p:nvPr/>
-        </p:nvSpPr>
-        <p:spPr>
-          <a:xfrm>
-            <a:off x="731520" y="1554480"/>
-            <a:ext cx="72720" cy="4571640"/>
-          </a:xfrm>
-          <a:prstGeom prst="rect">
-            <a:avLst/>
-          </a:prstGeom>
-          <a:solidFill>
-            <a:srgbClr val="24A148"/>
-          </a:solidFill>
-          <a:ln>
-            <a:noFill/>
-          </a:ln>
-          <a:effectLst>
-            <a:outerShdw blurRad="39960" dir="5400000" dist="23040" rotWithShape="0">
-              <a:srgbClr val="000000">
-                <a:alpha val="35000"/>
-              </a:srgbClr>
-            </a:outerShdw>
-          </a:effectLst>
-        </p:spPr>
-        <p:style>
-          <a:lnRef idx="1">
-            <a:schemeClr val="accent1"/>
-          </a:lnRef>
-          <a:fillRef idx="3">
-            <a:schemeClr val="accent1"/>
-          </a:fillRef>
-          <a:effectRef idx="2">
-            <a:schemeClr val="accent1"/>
-          </a:effectRef>
-          <a:fontRef idx="minor"/>
-        </p:style>
-        <p:txBody>
-          <a:bodyPr lIns="90000" tIns="45000" rIns="90000" bIns="45000" anchor="ctr">
-            <a:noAutofit/>
-          </a:bodyPr>
-          <a:p>
-            <a:endParaRPr lang="en-US" sz="1800" b="0" u="none" strike="noStrike">
-              <a:solidFill>
-                <a:schemeClr val="lt1"/>
-              </a:solidFill>
-              <a:effectLst/>
-              <a:uFillTx/>
-              <a:latin typeface="Calibri"/>
-            </a:endParaRPr>
-          </a:p>
-        </p:txBody>
-      </p:sp>
-      <p:sp>
-        <p:nvSpPr>
-          <p:cNvPr id="142" name="TextBox 7"/>
-          <p:cNvSpPr/>
-          <p:nvPr/>
-        </p:nvSpPr>
-        <p:spPr>
-          <a:xfrm>
-            <a:off x="1005840" y="1737360"/>
-            <a:ext cx="4571640" cy="2725560"/>
-          </a:xfrm>
-          <a:prstGeom prst="rect">
-            <a:avLst/>
-          </a:prstGeom>
-          <a:noFill/>
-          <a:ln w="0">
-            <a:noFill/>
-          </a:ln>
-        </p:spPr>
-        <p:style>
-          <a:lnRef idx="0"/>
-          <a:fillRef idx="0"/>
-          <a:effectRef idx="0"/>
-          <a:fontRef idx="minor"/>
-        </p:style>
-        <p:txBody>
-          <a:bodyPr lIns="0" tIns="0" rIns="0" bIns="0" anchor="t">
-            <a:spAutoFit/>
-          </a:bodyPr>
-          <a:p>
-            <a:pPr defTabSz="457200">
-              <a:lnSpc>
-                <a:spcPct val="100000"/>
-              </a:lnSpc>
-              <a:spcAft>
-                <a:spcPts val="2001"/>
-              </a:spcAft>
-            </a:pPr>
-            <a:r>
-              <a:rPr lang="en-US" sz="1200" b="1" u="none" strike="noStrike">
-                <a:solidFill>
-                  <a:srgbClr val="24A148"/>
-                </a:solidFill>
-                <a:effectLst/>
-                <a:uFillTx/>
-                <a:latin typeface="Calibri"/>
-              </a:rPr>
-              <a:t>EDGE-TEXTURED TRUE 3D MAP</a:t>
-            </a:r>
-            <a:endParaRPr lang="en-US" sz="1200" b="0" u="none" strike="noStrike">
-              <a:solidFill>
-                <a:srgbClr val="000000"/>
-              </a:solidFill>
-              <a:effectLst/>
-              <a:uFillTx/>
-              <a:latin typeface="Arial"/>
-            </a:endParaRPr>
-          </a:p>
-          <a:p>
-            <a:pPr defTabSz="457200">
-              <a:lnSpc>
-                <a:spcPct val="100000"/>
-              </a:lnSpc>
-              <a:spcAft>
-                <a:spcPts val="799"/>
-              </a:spcAft>
-            </a:pPr>
-            <a:r>
-              <a:rPr lang="en-US" sz="1300" b="1" u="none" strike="noStrike">
-                <a:solidFill>
-                  <a:srgbClr val="FFFFFF"/>
-                </a:solidFill>
-                <a:effectLst/>
-                <a:uFillTx/>
-                <a:latin typeface="IBM Plex Sans"/>
-              </a:rPr>
-              <a:t>• 최종 통합 매핑 솔루션</a:t>
-            </a:r>
-            <a:r>
-              <a:rPr lang="en-US" sz="1300" b="1" u="none" strike="noStrike">
-                <a:solidFill>
-                  <a:srgbClr val="FFFFFF"/>
-                </a:solidFill>
-                <a:effectLst/>
-                <a:uFillTx/>
-                <a:latin typeface="IBM Plex Sans"/>
-              </a:rPr>
-              <a:t>: </a:t>
-            </a:r>
-            <a:r>
-              <a:rPr lang="zh-CN" sz="1300" b="0" u="none" strike="noStrike">
-                <a:solidFill>
-                  <a:srgbClr val="C6C6C6"/>
-                </a:solidFill>
-                <a:effectLst/>
-                <a:uFillTx/>
-                <a:latin typeface="IBM Plex Sans"/>
-              </a:rPr>
-              <a:t>카메라의 에지와 </a:t>
-            </a:r>
-            <a:r>
-              <a:rPr lang="en-US" sz="1300" b="0" u="none" strike="noStrike">
-                <a:solidFill>
-                  <a:srgbClr val="C6C6C6"/>
-                </a:solidFill>
-                <a:effectLst/>
-                <a:uFillTx/>
-                <a:latin typeface="IBM Plex Sans"/>
-              </a:rPr>
-              <a:t>LiDAR </a:t>
-            </a:r>
-            <a:r>
-              <a:rPr lang="zh-CN" sz="1300" b="0" u="none" strike="noStrike">
-                <a:solidFill>
-                  <a:srgbClr val="C6C6C6"/>
-                </a:solidFill>
-                <a:effectLst/>
-                <a:uFillTx/>
-                <a:latin typeface="IBM Plex Sans"/>
-              </a:rPr>
-              <a:t>벽면 그리드를 결합하여 실제 벽면에 이미지를 입히는 최신 기법 적용</a:t>
-            </a:r>
-            <a:r>
-              <a:rPr lang="en-US" sz="1300" b="0" u="none" strike="noStrike">
-                <a:solidFill>
-                  <a:srgbClr val="C6C6C6"/>
-                </a:solidFill>
-                <a:effectLst/>
-                <a:uFillTx/>
-                <a:latin typeface="IBM Plex Sans"/>
-              </a:rPr>
-              <a:t>.</a:t>
-            </a:r>
-            <a:endParaRPr lang="en-US" sz="1300" b="0" u="none" strike="noStrike">
-              <a:solidFill>
-                <a:srgbClr val="000000"/>
-              </a:solidFill>
-              <a:effectLst/>
-              <a:uFillTx/>
-              <a:latin typeface="Arial"/>
-            </a:endParaRPr>
-          </a:p>
-          <a:p>
-            <a:pPr defTabSz="457200">
-              <a:lnSpc>
-                <a:spcPct val="100000"/>
-              </a:lnSpc>
-              <a:spcAft>
-                <a:spcPts val="799"/>
-              </a:spcAft>
-            </a:pPr>
-            <a:r>
-              <a:rPr lang="en-US" sz="1300" b="1" u="none" strike="noStrike">
-                <a:solidFill>
-                  <a:srgbClr val="FFFFFF"/>
-                </a:solidFill>
-                <a:effectLst/>
-                <a:uFillTx/>
-                <a:latin typeface="IBM Plex Sans"/>
-              </a:rPr>
-              <a:t>• Raycast </a:t>
-            </a:r>
-            <a:r>
-              <a:rPr lang="zh-CN" sz="1300" b="1" u="none" strike="noStrike">
-                <a:solidFill>
-                  <a:srgbClr val="FFFFFF"/>
-                </a:solidFill>
-                <a:effectLst/>
-                <a:uFillTx/>
-                <a:latin typeface="IBM Plex Sans"/>
-              </a:rPr>
-              <a:t>기반 매칭</a:t>
-            </a:r>
-            <a:r>
-              <a:rPr lang="en-US" sz="1300" b="1" u="none" strike="noStrike">
-                <a:solidFill>
-                  <a:srgbClr val="FFFFFF"/>
-                </a:solidFill>
-                <a:effectLst/>
-                <a:uFillTx/>
-                <a:latin typeface="IBM Plex Sans"/>
-              </a:rPr>
-              <a:t>: </a:t>
-            </a:r>
-            <a:r>
-              <a:rPr lang="zh-CN" sz="1300" b="0" u="none" strike="noStrike">
-                <a:solidFill>
-                  <a:srgbClr val="C6C6C6"/>
-                </a:solidFill>
-                <a:effectLst/>
-                <a:uFillTx/>
-                <a:latin typeface="IBM Plex Sans"/>
-              </a:rPr>
-              <a:t>각 </a:t>
-            </a:r>
-            <a:r>
-              <a:rPr lang="en-US" sz="1300" b="0" u="none" strike="noStrike">
-                <a:solidFill>
-                  <a:srgbClr val="C6C6C6"/>
-                </a:solidFill>
-                <a:effectLst/>
-                <a:uFillTx/>
-                <a:latin typeface="IBM Plex Sans"/>
-              </a:rPr>
-              <a:t>run</a:t>
-            </a:r>
-            <a:r>
-              <a:rPr lang="zh-CN" sz="1300" b="0" u="none" strike="noStrike">
-                <a:solidFill>
-                  <a:srgbClr val="C6C6C6"/>
-                </a:solidFill>
-                <a:effectLst/>
-                <a:uFillTx/>
-                <a:latin typeface="IBM Plex Sans"/>
-              </a:rPr>
-              <a:t>에서 </a:t>
-            </a:r>
-            <a:r>
-              <a:rPr lang="en-US" sz="1300" b="0" u="none" strike="noStrike">
-                <a:solidFill>
-                  <a:srgbClr val="C6C6C6"/>
-                </a:solidFill>
-                <a:effectLst/>
-                <a:uFillTx/>
-                <a:latin typeface="IBM Plex Sans"/>
-              </a:rPr>
-              <a:t>C920 </a:t>
-            </a:r>
-            <a:r>
-              <a:rPr lang="zh-CN" sz="1300" b="0" u="none" strike="noStrike">
-                <a:solidFill>
-                  <a:srgbClr val="C6C6C6"/>
-                </a:solidFill>
-                <a:effectLst/>
-                <a:uFillTx/>
-                <a:latin typeface="IBM Plex Sans"/>
-              </a:rPr>
-              <a:t>프레임 </a:t>
-            </a:r>
-            <a:r>
-              <a:rPr lang="en-US" sz="1300" b="0" u="none" strike="noStrike">
-                <a:solidFill>
-                  <a:srgbClr val="C6C6C6"/>
-                </a:solidFill>
-                <a:effectLst/>
-                <a:uFillTx/>
-                <a:latin typeface="IBM Plex Sans"/>
-              </a:rPr>
-              <a:t>18</a:t>
-            </a:r>
-            <a:r>
-              <a:rPr lang="zh-CN" sz="1300" b="0" u="none" strike="noStrike">
-                <a:solidFill>
-                  <a:srgbClr val="C6C6C6"/>
-                </a:solidFill>
-                <a:effectLst/>
-                <a:uFillTx/>
-                <a:latin typeface="IBM Plex Sans"/>
-              </a:rPr>
-              <a:t>개를 추출하고 </a:t>
-            </a:r>
-            <a:r>
-              <a:rPr lang="en-US" sz="1300" b="0" u="none" strike="noStrike">
-                <a:solidFill>
-                  <a:srgbClr val="C6C6C6"/>
-                </a:solidFill>
-                <a:effectLst/>
-                <a:uFillTx/>
-                <a:latin typeface="IBM Plex Sans"/>
-              </a:rPr>
-              <a:t>3</a:t>
-            </a:r>
-            <a:r>
-              <a:rPr lang="zh-CN" sz="1300" b="0" u="none" strike="noStrike">
-                <a:solidFill>
-                  <a:srgbClr val="C6C6C6"/>
-                </a:solidFill>
-                <a:effectLst/>
-                <a:uFillTx/>
-                <a:latin typeface="IBM Plex Sans"/>
-              </a:rPr>
-              <a:t>개 영역 패치로 분할</a:t>
-            </a:r>
-            <a:r>
-              <a:rPr lang="en-US" sz="1300" b="0" u="none" strike="noStrike">
-                <a:solidFill>
-                  <a:srgbClr val="C6C6C6"/>
-                </a:solidFill>
-                <a:effectLst/>
-                <a:uFillTx/>
-                <a:latin typeface="IBM Plex Sans"/>
-              </a:rPr>
-              <a:t>, Canny edge </a:t>
-            </a:r>
-            <a:r>
-              <a:rPr lang="zh-CN" sz="1300" b="0" u="none" strike="noStrike">
-                <a:solidFill>
-                  <a:srgbClr val="C6C6C6"/>
-                </a:solidFill>
-                <a:effectLst/>
-                <a:uFillTx/>
-                <a:latin typeface="IBM Plex Sans"/>
-              </a:rPr>
-              <a:t>및 </a:t>
-            </a:r>
-            <a:r>
-              <a:rPr lang="en-US" sz="1300" b="0" u="none" strike="noStrike">
-                <a:solidFill>
-                  <a:srgbClr val="C6C6C6"/>
-                </a:solidFill>
-                <a:effectLst/>
-                <a:uFillTx/>
-                <a:latin typeface="IBM Plex Sans"/>
-              </a:rPr>
-              <a:t>contour </a:t>
-            </a:r>
-            <a:r>
-              <a:rPr lang="zh-CN" sz="1300" b="0" u="none" strike="noStrike">
-                <a:solidFill>
-                  <a:srgbClr val="C6C6C6"/>
-                </a:solidFill>
-                <a:effectLst/>
-                <a:uFillTx/>
-                <a:latin typeface="IBM Plex Sans"/>
-              </a:rPr>
-              <a:t>계산 후 </a:t>
-            </a:r>
-            <a:r>
-              <a:rPr lang="en-US" sz="1300" b="0" u="none" strike="noStrike">
-                <a:solidFill>
-                  <a:srgbClr val="C6C6C6"/>
-                </a:solidFill>
-                <a:effectLst/>
-                <a:uFillTx/>
-                <a:latin typeface="IBM Plex Sans"/>
-              </a:rPr>
-              <a:t>LiDAR </a:t>
-            </a:r>
-            <a:r>
-              <a:rPr lang="zh-CN" sz="1300" b="0" u="none" strike="noStrike">
-                <a:solidFill>
-                  <a:srgbClr val="C6C6C6"/>
-                </a:solidFill>
-                <a:effectLst/>
-                <a:uFillTx/>
-                <a:latin typeface="IBM Plex Sans"/>
-              </a:rPr>
-              <a:t>바운더리에 매칭</a:t>
-            </a:r>
-            <a:r>
-              <a:rPr lang="en-US" sz="1300" b="0" u="none" strike="noStrike">
-                <a:solidFill>
-                  <a:srgbClr val="C6C6C6"/>
-                </a:solidFill>
-                <a:effectLst/>
-                <a:uFillTx/>
-                <a:latin typeface="IBM Plex Sans"/>
-              </a:rPr>
-              <a:t>.</a:t>
-            </a:r>
-            <a:endParaRPr lang="en-US" sz="1300" b="0" u="none" strike="noStrike">
-              <a:solidFill>
-                <a:srgbClr val="000000"/>
-              </a:solidFill>
-              <a:effectLst/>
-              <a:uFillTx/>
-              <a:latin typeface="Arial"/>
-            </a:endParaRPr>
-          </a:p>
-          <a:p>
-            <a:pPr defTabSz="457200">
-              <a:lnSpc>
-                <a:spcPct val="100000"/>
-              </a:lnSpc>
-              <a:spcAft>
-                <a:spcPts val="799"/>
-              </a:spcAft>
-            </a:pPr>
-            <a:r>
-              <a:rPr lang="en-US" sz="1300" b="1" u="none" strike="noStrike">
-                <a:solidFill>
-                  <a:srgbClr val="FFFFFF"/>
-                </a:solidFill>
-                <a:effectLst/>
-                <a:uFillTx/>
-                <a:latin typeface="IBM Plex Sans"/>
-              </a:rPr>
-              <a:t>• 수직 텍스처 패널 배치</a:t>
-            </a:r>
-            <a:r>
-              <a:rPr lang="en-US" sz="1300" b="1" u="none" strike="noStrike">
-                <a:solidFill>
-                  <a:srgbClr val="FFFFFF"/>
-                </a:solidFill>
-                <a:effectLst/>
-                <a:uFillTx/>
-                <a:latin typeface="IBM Plex Sans"/>
-              </a:rPr>
-              <a:t>: </a:t>
-            </a:r>
-            <a:r>
-              <a:rPr lang="zh-CN" sz="1300" b="0" u="none" strike="noStrike">
-                <a:solidFill>
-                  <a:srgbClr val="C6C6C6"/>
-                </a:solidFill>
-                <a:effectLst/>
-                <a:uFillTx/>
-                <a:latin typeface="IBM Plex Sans"/>
-              </a:rPr>
-              <a:t>실제 물체가 있는 곳에 </a:t>
-            </a:r>
-            <a:r>
-              <a:rPr lang="en-US" sz="1300" b="0" u="none" strike="noStrike">
-                <a:solidFill>
-                  <a:srgbClr val="C6C6C6"/>
-                </a:solidFill>
-                <a:effectLst/>
-                <a:uFillTx/>
-                <a:latin typeface="IBM Plex Sans"/>
-              </a:rPr>
-              <a:t>90</a:t>
-            </a:r>
-            <a:r>
-              <a:rPr lang="zh-CN" sz="1300" b="0" u="none" strike="noStrike">
-                <a:solidFill>
-                  <a:srgbClr val="C6C6C6"/>
-                </a:solidFill>
-                <a:effectLst/>
-                <a:uFillTx/>
-                <a:latin typeface="IBM Plex Sans"/>
-              </a:rPr>
-              <a:t>개의 </a:t>
-            </a:r>
-            <a:r>
-              <a:rPr lang="en-US" sz="1300" b="0" u="none" strike="noStrike">
-                <a:solidFill>
-                  <a:srgbClr val="C6C6C6"/>
-                </a:solidFill>
-                <a:effectLst/>
-                <a:uFillTx/>
-                <a:latin typeface="IBM Plex Sans"/>
-              </a:rPr>
-              <a:t>Edge-textured vertical panel</a:t>
-            </a:r>
-            <a:r>
-              <a:rPr lang="zh-CN" sz="1300" b="0" u="none" strike="noStrike">
-                <a:solidFill>
-                  <a:srgbClr val="C6C6C6"/>
-                </a:solidFill>
-                <a:effectLst/>
-                <a:uFillTx/>
-                <a:latin typeface="IBM Plex Sans"/>
-              </a:rPr>
-              <a:t>을 적재적소에 빌딩함</a:t>
-            </a:r>
-            <a:r>
-              <a:rPr lang="en-US" sz="1300" b="0" u="none" strike="noStrike">
-                <a:solidFill>
-                  <a:srgbClr val="C6C6C6"/>
-                </a:solidFill>
-                <a:effectLst/>
-                <a:uFillTx/>
-                <a:latin typeface="IBM Plex Sans"/>
-              </a:rPr>
-              <a:t>.</a:t>
-            </a:r>
-            <a:endParaRPr lang="en-US" sz="1300" b="0" u="none" strike="noStrike">
-              <a:solidFill>
-                <a:srgbClr val="000000"/>
-              </a:solidFill>
-              <a:effectLst/>
-              <a:uFillTx/>
-              <a:latin typeface="Arial"/>
-            </a:endParaRPr>
-          </a:p>
-          <a:p>
-            <a:pPr defTabSz="457200">
-              <a:lnSpc>
-                <a:spcPct val="100000"/>
-              </a:lnSpc>
-              <a:spcAft>
-                <a:spcPts val="799"/>
-              </a:spcAft>
-            </a:pPr>
-            <a:r>
-              <a:rPr lang="en-US" sz="1300" b="1" u="none" strike="noStrike">
-                <a:solidFill>
-                  <a:srgbClr val="FFFFFF"/>
-                </a:solidFill>
-                <a:effectLst/>
-                <a:uFillTx/>
-                <a:latin typeface="IBM Plex Sans"/>
-              </a:rPr>
-              <a:t>• 좌표 축 </a:t>
-            </a:r>
-            <a:r>
-              <a:rPr lang="en-US" sz="1300" b="1" u="none" strike="noStrike">
-                <a:solidFill>
-                  <a:srgbClr val="FFFFFF"/>
-                </a:solidFill>
-                <a:effectLst/>
-                <a:uFillTx/>
-                <a:latin typeface="IBM Plex Sans"/>
-              </a:rPr>
-              <a:t>Yaw </a:t>
-            </a:r>
-            <a:r>
-              <a:rPr lang="zh-CN" sz="1300" b="1" u="none" strike="noStrike">
-                <a:solidFill>
-                  <a:srgbClr val="FFFFFF"/>
-                </a:solidFill>
-                <a:effectLst/>
-                <a:uFillTx/>
-                <a:latin typeface="IBM Plex Sans"/>
-              </a:rPr>
-              <a:t>버그 해결</a:t>
-            </a:r>
-            <a:r>
-              <a:rPr lang="en-US" sz="1300" b="1" u="none" strike="noStrike">
-                <a:solidFill>
-                  <a:srgbClr val="FFFFFF"/>
-                </a:solidFill>
-                <a:effectLst/>
-                <a:uFillTx/>
-                <a:latin typeface="IBM Plex Sans"/>
-              </a:rPr>
-              <a:t>: </a:t>
-            </a:r>
-            <a:r>
-              <a:rPr lang="en-US" sz="1300" b="0" u="none" strike="noStrike">
-                <a:solidFill>
-                  <a:srgbClr val="C6C6C6"/>
-                </a:solidFill>
-                <a:effectLst/>
-                <a:uFillTx/>
-                <a:latin typeface="IBM Plex Sans"/>
-              </a:rPr>
-              <a:t>ROS(odom) </a:t>
-            </a:r>
-            <a:r>
-              <a:rPr lang="zh-CN" sz="1300" b="0" u="none" strike="noStrike">
-                <a:solidFill>
-                  <a:srgbClr val="C6C6C6"/>
-                </a:solidFill>
-                <a:effectLst/>
-                <a:uFillTx/>
-                <a:latin typeface="IBM Plex Sans"/>
-              </a:rPr>
-              <a:t>좌표계와 </a:t>
-            </a:r>
-            <a:r>
-              <a:rPr lang="en-US" sz="1300" b="0" u="none" strike="noStrike">
-                <a:solidFill>
-                  <a:srgbClr val="C6C6C6"/>
-                </a:solidFill>
-                <a:effectLst/>
-                <a:uFillTx/>
-                <a:latin typeface="IBM Plex Sans"/>
-              </a:rPr>
-              <a:t>WebGL</a:t>
-            </a:r>
-            <a:r>
-              <a:rPr lang="zh-CN" sz="1300" b="0" u="none" strike="noStrike">
-                <a:solidFill>
-                  <a:srgbClr val="C6C6C6"/>
-                </a:solidFill>
-                <a:effectLst/>
-                <a:uFillTx/>
-                <a:latin typeface="IBM Plex Sans"/>
-              </a:rPr>
-              <a:t>의 카메라 </a:t>
-            </a:r>
-            <a:r>
-              <a:rPr lang="en-US" sz="1300" b="0" u="none" strike="noStrike">
-                <a:solidFill>
-                  <a:srgbClr val="C6C6C6"/>
-                </a:solidFill>
-                <a:effectLst/>
-                <a:uFillTx/>
-                <a:latin typeface="IBM Plex Sans"/>
-              </a:rPr>
-              <a:t>forward </a:t>
-            </a:r>
-            <a:r>
-              <a:rPr lang="zh-CN" sz="1300" b="0" u="none" strike="noStrike">
-                <a:solidFill>
-                  <a:srgbClr val="C6C6C6"/>
-                </a:solidFill>
-                <a:effectLst/>
-                <a:uFillTx/>
-                <a:latin typeface="IBM Plex Sans"/>
-              </a:rPr>
-              <a:t>축 불일치를 보정하여 </a:t>
-            </a:r>
-            <a:r>
-              <a:rPr lang="en-US" sz="1300" b="0" u="none" strike="noStrike">
-                <a:solidFill>
-                  <a:srgbClr val="C6C6C6"/>
-                </a:solidFill>
-                <a:effectLst/>
-                <a:uFillTx/>
-                <a:latin typeface="IBM Plex Sans"/>
-              </a:rPr>
-              <a:t>(`camera.yaw = pi/2 - panel.yaw`) </a:t>
-            </a:r>
-            <a:r>
-              <a:rPr lang="zh-CN" sz="1300" b="0" u="none" strike="noStrike">
-                <a:solidFill>
-                  <a:srgbClr val="C6C6C6"/>
-                </a:solidFill>
-                <a:effectLst/>
-                <a:uFillTx/>
-                <a:latin typeface="IBM Plex Sans"/>
-              </a:rPr>
-              <a:t>정확한 시선 일치 성공</a:t>
-            </a:r>
-            <a:r>
-              <a:rPr lang="en-US" sz="1300" b="0" u="none" strike="noStrike">
-                <a:solidFill>
-                  <a:srgbClr val="C6C6C6"/>
-                </a:solidFill>
-                <a:effectLst/>
-                <a:uFillTx/>
-                <a:latin typeface="IBM Plex Sans"/>
-              </a:rPr>
-              <a:t>.</a:t>
-            </a:r>
-            <a:endParaRPr lang="en-US" sz="1300" b="0" u="none" strike="noStrike">
-              <a:solidFill>
-                <a:srgbClr val="000000"/>
-              </a:solidFill>
-              <a:effectLst/>
-              <a:uFillTx/>
-              <a:latin typeface="Arial"/>
-            </a:endParaRPr>
-          </a:p>
-        </p:txBody>
-      </p:sp>
-      <p:sp>
-        <p:nvSpPr>
-          <p:cNvPr id="143" name="Rectangle 8"/>
-          <p:cNvSpPr/>
-          <p:nvPr/>
-        </p:nvSpPr>
-        <p:spPr>
-          <a:xfrm>
-            <a:off x="6309360" y="1554480"/>
-            <a:ext cx="5120280" cy="4571640"/>
-          </a:xfrm>
-          <a:prstGeom prst="rect">
-            <a:avLst/>
-          </a:prstGeom>
-          <a:solidFill>
-            <a:srgbClr val="262626"/>
-          </a:solidFill>
-          <a:ln w="12700">
-            <a:solidFill>
-              <a:srgbClr val="393939"/>
-            </a:solidFill>
-            <a:round/>
-          </a:ln>
-          <a:effectLst>
-            <a:outerShdw blurRad="39960" dir="5400000" dist="23040" rotWithShape="0">
-              <a:srgbClr val="000000">
-                <a:alpha val="35000"/>
-              </a:srgbClr>
-            </a:outerShdw>
-          </a:effectLst>
-        </p:spPr>
-        <p:style>
-          <a:lnRef idx="1">
-            <a:schemeClr val="accent1"/>
-          </a:lnRef>
-          <a:fillRef idx="3">
-            <a:schemeClr val="accent1"/>
-          </a:fillRef>
-          <a:effectRef idx="2">
-            <a:schemeClr val="accent1"/>
-          </a:effectRef>
-          <a:fontRef idx="minor"/>
-        </p:style>
-        <p:txBody>
-          <a:bodyPr lIns="90000" tIns="45000" rIns="90000" bIns="45000" anchor="ctr">
-            <a:noAutofit/>
-          </a:bodyPr>
-          <a:p>
-            <a:endParaRPr lang="en-US" sz="1800" b="0" u="none" strike="noStrike">
-              <a:solidFill>
-                <a:schemeClr val="lt1"/>
-              </a:solidFill>
-              <a:effectLst/>
-              <a:uFillTx/>
-              <a:latin typeface="Calibri"/>
-            </a:endParaRPr>
-          </a:p>
-        </p:txBody>
-      </p:sp>
-      <p:sp>
-        <p:nvSpPr>
-          <p:cNvPr id="144" name="Rectangle 9"/>
-          <p:cNvSpPr/>
-          <p:nvPr/>
-        </p:nvSpPr>
-        <p:spPr>
-          <a:xfrm>
-            <a:off x="6309360" y="1554480"/>
-            <a:ext cx="72720" cy="4571640"/>
-          </a:xfrm>
-          <a:prstGeom prst="rect">
-            <a:avLst/>
-          </a:prstGeom>
-          <a:solidFill>
-            <a:srgbClr val="393939"/>
-          </a:solidFill>
-          <a:ln>
-            <a:noFill/>
-          </a:ln>
-          <a:effectLst>
-            <a:outerShdw blurRad="39960" dir="5400000" dist="23040" rotWithShape="0">
-              <a:srgbClr val="000000">
-                <a:alpha val="35000"/>
-              </a:srgbClr>
-            </a:outerShdw>
-          </a:effectLst>
-        </p:spPr>
-        <p:style>
-          <a:lnRef idx="1">
-            <a:schemeClr val="accent1"/>
-          </a:lnRef>
-          <a:fillRef idx="3">
-            <a:schemeClr val="accent1"/>
-          </a:fillRef>
-          <a:effectRef idx="2">
-            <a:schemeClr val="accent1"/>
-          </a:effectRef>
-          <a:fontRef idx="minor"/>
-        </p:style>
-        <p:txBody>
-          <a:bodyPr lIns="90000" tIns="45000" rIns="90000" bIns="45000" anchor="ctr">
-            <a:noAutofit/>
-          </a:bodyPr>
-          <a:p>
-            <a:endParaRPr lang="en-US" sz="1800" b="0" u="none" strike="noStrike">
-              <a:solidFill>
-                <a:schemeClr val="lt1"/>
-              </a:solidFill>
-              <a:effectLst/>
-              <a:uFillTx/>
-              <a:latin typeface="Calibri"/>
-            </a:endParaRPr>
-          </a:p>
-        </p:txBody>
-      </p:sp>
-      <p:pic>
-        <p:nvPicPr>
-          <p:cNvPr id="145" name="Picture 10" descr="최종_Edge_textured_3D_map_desktop.jpeg"/>
-          <p:cNvPicPr/>
-          <p:nvPr/>
-        </p:nvPicPr>
-        <p:blipFill>
-          <a:blip r:embed="rId1"/>
-          <a:stretch/>
-        </p:blipFill>
-        <p:spPr>
-          <a:xfrm>
-            <a:off x="6492240" y="1737360"/>
-            <a:ext cx="4754520" cy="3474360"/>
-          </a:xfrm>
-          <a:prstGeom prst="rect">
-            <a:avLst/>
-          </a:prstGeom>
-          <a:noFill/>
-          <a:ln w="0">
-            <a:noFill/>
-          </a:ln>
-        </p:spPr>
-      </p:pic>
-      <p:sp>
-        <p:nvSpPr>
-          <p:cNvPr id="146" name="TextBox 11"/>
-          <p:cNvSpPr/>
-          <p:nvPr/>
-        </p:nvSpPr>
-        <p:spPr>
-          <a:xfrm>
-            <a:off x="6492240" y="5303520"/>
-            <a:ext cx="4754520" cy="731160"/>
-          </a:xfrm>
-          <a:prstGeom prst="rect">
-            <a:avLst/>
-          </a:prstGeom>
-          <a:noFill/>
-          <a:ln w="0">
-            <a:noFill/>
-          </a:ln>
-        </p:spPr>
-        <p:style>
-          <a:lnRef idx="0"/>
-          <a:fillRef idx="0"/>
-          <a:effectRef idx="0"/>
-          <a:fontRef idx="minor"/>
-        </p:style>
-        <p:txBody>
-          <a:bodyPr lIns="0" tIns="0" rIns="0" bIns="0" anchor="t">
-            <a:spAutoFit/>
-          </a:bodyPr>
-          <a:p>
-            <a:pPr defTabSz="457200">
-              <a:lnSpc>
-                <a:spcPct val="100000"/>
-              </a:lnSpc>
-            </a:pPr>
-            <a:r>
-              <a:rPr lang="en-US" sz="1100" b="0" u="none" strike="noStrike">
-                <a:solidFill>
-                  <a:srgbClr val="8D8D8D"/>
-                </a:solidFill>
-                <a:effectLst/>
-                <a:uFillTx/>
-                <a:latin typeface="IBM Plex Sans"/>
-              </a:rPr>
-              <a:t>▲ 최종 완성된 </a:t>
-            </a:r>
-            <a:r>
-              <a:rPr lang="en-US" sz="1100" b="0" u="none" strike="noStrike">
-                <a:solidFill>
-                  <a:srgbClr val="8D8D8D"/>
-                </a:solidFill>
-                <a:effectLst/>
-                <a:uFillTx/>
-                <a:latin typeface="IBM Plex Sans"/>
-              </a:rPr>
-              <a:t>Edge-textured 3D map WebGL </a:t>
-            </a:r>
-            <a:r>
-              <a:rPr lang="zh-CN" sz="1100" b="0" u="none" strike="noStrike">
-                <a:solidFill>
-                  <a:srgbClr val="8D8D8D"/>
-                </a:solidFill>
-                <a:effectLst/>
-                <a:uFillTx/>
-                <a:latin typeface="IBM Plex Sans"/>
-              </a:rPr>
-              <a:t>뷰어 </a:t>
-            </a:r>
-            <a:r>
-              <a:rPr lang="en-US" sz="1100" b="0" u="none" strike="noStrike">
-                <a:solidFill>
-                  <a:srgbClr val="8D8D8D"/>
-                </a:solidFill>
-                <a:effectLst/>
-                <a:uFillTx/>
-                <a:latin typeface="IBM Plex Sans"/>
-              </a:rPr>
-              <a:t>PC </a:t>
-            </a:r>
-            <a:r>
-              <a:rPr lang="zh-CN" sz="1100" b="0" u="none" strike="noStrike">
-                <a:solidFill>
-                  <a:srgbClr val="8D8D8D"/>
-                </a:solidFill>
-                <a:effectLst/>
-                <a:uFillTx/>
-                <a:latin typeface="IBM Plex Sans"/>
-              </a:rPr>
-              <a:t>화면</a:t>
             </a:r>
             <a:endParaRPr lang="en-US" sz="1100" b="0" u="none" strike="noStrike">
               <a:solidFill>

</xml_diff>